<commit_message>
Ajustes finais para a entrega
- Valores lógicos exibidos como verdadeiro/falso (codegen e testes)
- Relatório: três decisões próprias reescritas com comparação à BIRL-Lite,
  justificativa do Python, alfabeto Σ, integrantes e declaração de uso de IA
- Relatório .docx e .pdf regenerados a partir das mesmas mudanças do .md
- Apresentação: integrantes no slide 1, decisões no slide 14 e notas sem
  textos de orientação da IA
- README: referências a arquivos inexistentes removidas
- Registro de validação e arquivos gerados atualizados

Co-Authored-By: Claude Opus 5.5 <noreply@anthropic.com>
Claude-Session: https://claude.ai/code/session_01PW8Rc3ZxdQvL2hx9s4LSh8
</commit_message>
<xml_diff>
--- a/docs/apresentacao.pptx
+++ b/docs/apresentacao.pptx
@@ -598,12 +598,6 @@
             <a:r>
               <a:t>“A MemeScript é nossa proposta de linguagem baseada em memes. Ela possui tipos explícitos e um transpilador para Python. Vamos mostrar a especificação, as etapas de análise e a execução de exemplos válidos e inválidos.”</a:t>
             </a:r>
-            <a:br/>
-            <a:br/>
-            <a:br/>
-            <a:r>
-              <a:t>Fonte dos requisitos: Trabalho_Pratico_1_Linguagem_Tematica_v6.md, documento fornecido pelo aluno. Implementação: MemeScript 1.0.</a:t>
-            </a:r>
             <a:endParaRPr/>
           </a:p>
         </p:txBody>
@@ -680,10 +674,6 @@
             <a:r>
               <a:t>Fonte: exemplos/02_valido_completo.meme. Entrada 10. Preço por café 4.50. Saída conferida por teste de integração com o arquivo .out.</a:t>
             </a:r>
-            <a:br/>
-            <a:r>
-              <a:t>Fonte dos requisitos: Trabalho_Pratico_1_Linguagem_Tematica_v6.md, documento fornecido pelo aluno. Implementação: MemeScript 1.0.</a:t>
-            </a:r>
             <a:endParaRPr/>
           </a:p>
         </p:txBody>
@@ -760,10 +750,6 @@
             <a:r>
               <a:t>Executar na pasta do projeto. Linux: python3. Windows: python ou py -3. Acrescentar --tokens e --symbols à inspeção quando útil. O comando python demo.py demonstra todos os exemplos.</a:t>
             </a:r>
-            <a:br/>
-            <a:r>
-              <a:t>Fonte dos requisitos: Trabalho_Pratico_1_Linguagem_Tematica_v6.md, documento fornecido pelo aluno. Implementação: MemeScript 1.0.</a:t>
-            </a:r>
             <a:endParaRPr/>
           </a:p>
         </p:txBody>
@@ -840,10 +826,6 @@
             <a:r>
               <a:t>Mostrar os arquivos 03, 04 e 05 com --check. Mostrar também 07 para incompatibilidade de tipos. Um arquivo Python antigo permanece intacto, conforme teste de CLI.</a:t>
             </a:r>
-            <a:br/>
-            <a:r>
-              <a:t>Fonte dos requisitos: Trabalho_Pratico_1_Linguagem_Tematica_v6.md, documento fornecido pelo aluno. Implementação: MemeScript 1.0.</a:t>
-            </a:r>
             <a:endParaRPr/>
           </a:p>
         </p:txBody>
@@ -920,10 +902,6 @@
             <a:r>
               <a:t>Resultado desta versão: 32 métodos, alguns com subcasos, passaram em Linux com Python 3.12.14. Não representa benchmark. Registro: docs/resultados_validacao.txt.</a:t>
             </a:r>
-            <a:br/>
-            <a:r>
-              <a:t>Fonte dos requisitos: Trabalho_Pratico_1_Linguagem_Tematica_v6.md, documento fornecido pelo aluno. Implementação: MemeScript 1.0.</a:t>
-            </a:r>
             <a:endParaRPr/>
           </a:p>
         </p:txBody>
@@ -993,21 +971,12 @@
           <a:lstStyle xmlns:a="http://schemas.openxmlformats.org/drawingml/2006/main"/>
           <a:p xmlns:a="http://schemas.openxmlformats.org/drawingml/2006/main">
             <a:r>
-              <a:t>“As principais decisões são o vocabulário, os tipos com escopo global e o fechamento explícito de blocos com geração por AST. Python simplifica a execução do destino, enquanto a MemeScript mantém suas próprias regras estáticas. A versão não possui funções ou vetores. Divisão por zero e entrada inadequada são erros de execução, e não de forma ou de tipos.”</a:t>
+              <a:t>“Nossas três decisões próprias mudam a gramática em relação à BIRL-Lite. Primeiro, a atribuição começa com RECEBA, então todo comando começa com uma palavra reservada e o parser decide pelo primeiro token. Segundo, as declarações ficam numa seção no início do programa e sempre têm valor inicial. Terceiro, ATA fecha os blocos e JA_ACABOU_JESSICA fecha o programa, enquanto a BIRL usa a mesma palavra para tudo. Python foi o destino informado ao professor no primeiro marco, e a verificação de tipos é toda da MemeScript. A versão não tem funções nem vetores; divisão por zero e entrada inválida são erros de execução.”</a:t>
             </a:r>
             <a:br/>
             <a:br/>
             <a:r>
-              <a:t>Se perguntarem sobre IA: “Esta versão recebeu assistência de IA na elaboração do material, código e testes. A equipe precisa revisar, adaptar e estudar a solução, conforme a autorização e as regras do professor.” Não afirmem ter obtido autorização sem confirmar isso.</a:t>
-            </a:r>
-            <a:br/>
-            <a:br/>
-            <a:r>
-              <a:t>A equipe deve informar e justificar Python ao professor no primeiro marco e verificar as regras de autorização de IA. Completar a identificação dos demais integrantes antes da entrega.</a:t>
-            </a:r>
-            <a:br/>
-            <a:r>
-              <a:t>Fonte dos requisitos: Trabalho_Pratico_1_Linguagem_Tematica_v6.md, documento fornecido pelo aluno. Implementação: MemeScript 1.0.</a:t>
+              <a:t>Sobre IA: usamos o ChatGPT no desenvolvimento e o Claude na revisão final do relatório, da apresentação e do código. Todo o material foi revisado e testado pelo grupo.</a:t>
             </a:r>
             <a:endParaRPr/>
           </a:p>
@@ -1094,12 +1063,6 @@
             </a:r>
             <a:endParaRPr/>
           </a:p>
-          <a:p xmlns:a="http://schemas.openxmlformats.org/drawingml/2006/main">
-            <a:r>
-              <a:t>Fonte dos requisitos: Trabalho_Pratico_1_Linguagem_Tematica_v6.md, documento fornecido pelo aluno. Implementação: MemeScript 1.0.</a:t>
-            </a:r>
-            <a:endParaRPr/>
-          </a:p>
         </p:txBody>
       </p:sp>
       <p:sp>
@@ -1169,12 +1132,6 @@
             <a:r>
               <a:t>“A linguagem declara inteiro, real e texto. Exigimos inicialização e um único escopo global, com todas as declarações antes dos comandos. Um inteiro pode virar real, mas um real não vira inteiro implicitamente. A divisão sempre produz real. Comparações produzem o tipo lógico interno usado nas condições.”</a:t>
             </a:r>
-            <a:br/>
-            <a:br/>
-            <a:br/>
-            <a:r>
-              <a:t>Fonte dos requisitos: Trabalho_Pratico_1_Linguagem_Tematica_v6.md, documento fornecido pelo aluno. Implementação: MemeScript 1.0.</a:t>
-            </a:r>
             <a:endParaRPr/>
           </a:p>
         </p:txBody>
@@ -1251,10 +1208,6 @@
             <a:r>
               <a:t>Arquivos correspondentes: lexer.py, parser.py, semantic.py e codegen.py. compiler.py coordena as fases.</a:t>
             </a:r>
-            <a:br/>
-            <a:r>
-              <a:t>Fonte dos requisitos: Trabalho_Pratico_1_Linguagem_Tematica_v6.md, documento fornecido pelo aluno. Implementação: MemeScript 1.0.</a:t>
-            </a:r>
             <a:endParaRPr/>
           </a:p>
         </p:txBody>
@@ -1331,10 +1284,6 @@
             <a:r>
               <a:t>O exemplo também contém =, *, 3, 4 e ;. A tabela destaca algumas categorias. Sigma: valores escalares Unicode em UTF-8. Identificadores usam ASCII.</a:t>
             </a:r>
-            <a:br/>
-            <a:r>
-              <a:t>Fonte dos requisitos: Trabalho_Pratico_1_Linguagem_Tematica_v6.md, documento fornecido pelo aluno. Implementação: MemeScript 1.0.</a:t>
-            </a:r>
             <a:endParaRPr/>
           </a:p>
         </p:txBody>
@@ -1421,9 +1370,6 @@
             <a:endParaRPr/>
           </a:p>
           <a:p xmlns:a="http://schemas.openxmlformats.org/drawingml/2006/main">
-            <a:r>
-              <a:t>Fonte dos requisitos: Trabalho_Pratico_1_Linguagem_Tematica_v6.md, documento fornecido pelo aluno. Implementação: MemeScript 1.0.</a:t>
-            </a:r>
             <a:endParaRPr/>
           </a:p>
           <a:p xmlns:a="http://schemas.openxmlformats.org/drawingml/2006/main">
@@ -1512,10 +1458,6 @@
             <a:r>
               <a:t>Os trechos mostram um esquema resumido da AST, com literais abreviados e campos omitidos. A JSON completa tem node, value, type_name, line e column. Mostrar --ast no terminal.</a:t>
             </a:r>
-            <a:br/>
-            <a:r>
-              <a:t>Fonte dos requisitos: Trabalho_Pratico_1_Linguagem_Tematica_v6.md, documento fornecido pelo aluno. Implementação: MemeScript 1.0.</a:t>
-            </a:r>
             <a:endParaRPr/>
           </a:p>
         </p:txBody>
@@ -1592,10 +1534,6 @@
             <a:r>
               <a:t>Exemplo de estrutura válida e incompatibilidade detectada depois do parsing. A tabela real de símbolos é um dicionário Python. O tipo lógico é interno, não declarável.</a:t>
             </a:r>
-            <a:br/>
-            <a:r>
-              <a:t>Fonte dos requisitos: Trabalho_Pratico_1_Linguagem_Tematica_v6.md, documento fornecido pelo aluno. Implementação: MemeScript 1.0.</a:t>
-            </a:r>
             <a:endParaRPr/>
           </a:p>
         </p:txBody>
@@ -1671,10 +1609,6 @@
             <a:br/>
             <a:r>
               <a:t>Trechos de fonte e destino. O gerador visita nós e não substitui palavras. Variáveis reais recebem float na atribuição. Literais de texto usam repr.</a:t>
-            </a:r>
-            <a:br/>
-            <a:r>
-              <a:t>Fonte dos requisitos: Trabalho_Pratico_1_Linguagem_Tematica_v6.md, documento fornecido pelo aluno. Implementação: MemeScript 1.0.</a:t>
             </a:r>
             <a:endParaRPr/>
           </a:p>
@@ -2901,8 +2835,8 @@
         </p:nvSpPr>
         <p:spPr>
           <a:xfrm xmlns:a="http://schemas.openxmlformats.org/drawingml/2006/main">
-            <a:off x="640080" y="5394960"/>
-            <a:ext cx="6400800" cy="822960"/>
+            <a:off x="640080" y="5212080"/>
+            <a:ext cx="6400800" cy="1005840"/>
           </a:xfrm>
           <a:prstGeom xmlns:a="http://schemas.openxmlformats.org/drawingml/2006/main" prst="rect">
             <a:avLst/>
@@ -2936,7 +2870,21 @@
                   <a:schemeClr val="accent6"/>
                 </a:solidFill>
               </a:rPr>
-              <a:t>Grupo de Pedro Rockenbach Frosi</a:t>
+              <a:t>Cristian dos Santos Siqueira · Marco Antônio Hendges</a:t>
+            </a:r>
+            <a:endParaRPr sz="1600"/>
+          </a:p>
+          <a:p xmlns:a="http://schemas.openxmlformats.org/drawingml/2006/main">
+            <a:pPr marL="0" indent="0">
+              <a:buNone/>
+            </a:pPr>
+            <a:r>
+              <a:rPr sz="1600">
+                <a:solidFill>
+                  <a:schemeClr val="accent6"/>
+                </a:solidFill>
+              </a:rPr>
+              <a:t>Pedro Rockenbach Frosi · William Rafael Fagundes</a:t>
             </a:r>
             <a:endParaRPr sz="1600"/>
           </a:p>
@@ -7186,7 +7134,7 @@
                   <a:schemeClr val="bg1"/>
                 </a:solidFill>
               </a:rPr>
-              <a:t>Vocabulário que sugere a operação</a:t>
+              <a:t>Atribuição com palavra reservada: RECEBA x = e;</a:t>
             </a:r>
             <a:endParaRPr sz="1800"/>
           </a:p>
@@ -7285,7 +7233,7 @@
                   <a:schemeClr val="bg1"/>
                 </a:solidFill>
               </a:rPr>
-              <a:t>Tipos explícitos e escopo global</a:t>
+              <a:t>Declarações no início, sempre com valor inicial</a:t>
             </a:r>
             <a:endParaRPr sz="1800"/>
           </a:p>
@@ -7384,7 +7332,7 @@
                   <a:schemeClr val="bg1"/>
                 </a:solidFill>
               </a:rPr>
-              <a:t>Blocos fechados e geração por AST</a:t>
+              <a:t>ATA fecha blocos; JA_ACABOU_JESSICA fecha o programa</a:t>
             </a:r>
             <a:endParaRPr sz="1800"/>
           </a:p>
@@ -7753,7 +7701,7 @@
                   <a:schemeClr val="tx1"/>
                 </a:solidFill>
               </a:rPr>
-              <a:t>Esta versão contou com assistência de IA na elaboração</a:t>
+              <a:t>IA utilizada: ChatGPT no desenvolvimento e Claude na revisão final; material testado pelo grupo</a:t>
             </a:r>
             <a:endParaRPr sz="1800"/>
           </a:p>

</xml_diff>

<commit_message>
Apresentação: slides de decisões e de alfabeto, G=(V,T,P,S)
- Novo slide 4 com as três decisões próprias comparadas à BIRL-Lite
- Novo slide 6 com o alfabeto Σ e as expressões regulares dos tokens
- Slide de gramática mostra G = (V, T, P, S)
- Último slide renomeado para "Resumo: decisões e limites"

Co-Authored-By: Claude Opus 5.5 <noreply@anthropic.com>
Claude-Session: https://claude.ai/code/session_01PW8Rc3ZxdQvL2hx9s4LSh8
</commit_message>
<xml_diff>
--- a/docs/apresentacao.pptx
+++ b/docs/apresentacao.pptx
@@ -11,7 +11,9 @@
     <p:sldId xmlns:r="http://schemas.openxmlformats.org/officeDocument/2006/relationships" id="256" r:id="R7bb8d22069584399"/>
     <p:sldId xmlns:r="http://schemas.openxmlformats.org/officeDocument/2006/relationships" id="257" r:id="Re40de3aeaa8142a1"/>
     <p:sldId xmlns:r="http://schemas.openxmlformats.org/officeDocument/2006/relationships" id="258" r:id="Rd73e779da07e4de2"/>
+    <p:sldId xmlns:r="http://schemas.openxmlformats.org/officeDocument/2006/relationships" id="270" r:id="rId1"/>
     <p:sldId xmlns:r="http://schemas.openxmlformats.org/officeDocument/2006/relationships" id="259" r:id="Rfcbf0f4b33a140dd"/>
+    <p:sldId xmlns:r="http://schemas.openxmlformats.org/officeDocument/2006/relationships" id="271" r:id="rId2"/>
     <p:sldId xmlns:r="http://schemas.openxmlformats.org/officeDocument/2006/relationships" id="260" r:id="R49a6097d11c14253"/>
     <p:sldId xmlns:r="http://schemas.openxmlformats.org/officeDocument/2006/relationships" id="261" r:id="Re2bb170225c04dc3"/>
     <p:sldId xmlns:r="http://schemas.openxmlformats.org/officeDocument/2006/relationships" id="262" r:id="R9e8b9a1dc39e443d"/>
@@ -1007,6 +1009,146 @@
 </p:notes>
 </file>
 
+<file path=ppt/notesSlides/notesSlide15.xml><?xml version="1.0" encoding="utf-8"?>
+<p:notes xmlns:a="http://schemas.openxmlformats.org/drawingml/2006/main" xmlns:p="http://schemas.openxmlformats.org/presentationml/2006/main" xmlns:r="http://schemas.openxmlformats.org/officeDocument/2006/relationships">
+  <p:cSld>
+    <p:spTree>
+      <p:nvGrpSpPr>
+        <p:cNvPr id="1" name=""/>
+        <p:cNvGrpSpPr/>
+        <p:nvPr/>
+      </p:nvGrpSpPr>
+      <p:grpSpPr>
+        <a:xfrm>
+          <a:off x="0" y="0"/>
+          <a:ext cx="0" cy="0"/>
+          <a:chOff x="0" y="0"/>
+          <a:chExt cx="0" cy="0"/>
+        </a:xfrm>
+      </p:grpSpPr>
+      <p:sp>
+        <p:nvSpPr>
+          <p:cNvPr id="2" name="Slide Image Placeholder 1"/>
+          <p:cNvSpPr>
+            <a:spLocks noGrp="1"/>
+          </p:cNvSpPr>
+          <p:nvPr>
+            <p:ph type="sldImg" idx="2"/>
+          </p:nvPr>
+        </p:nvSpPr>
+        <p:spPr/>
+      </p:sp>
+      <p:sp>
+        <p:nvSpPr>
+          <p:cNvPr id="3" name="Notes Placeholder 2"/>
+          <p:cNvSpPr>
+            <a:spLocks noGrp="1"/>
+          </p:cNvSpPr>
+          <p:nvPr>
+            <p:ph type="body" idx="3" sz="quarter"/>
+          </p:nvPr>
+        </p:nvSpPr>
+        <p:spPr/>
+        <p:txBody>
+          <a:bodyPr/>
+          <a:lstStyle/>
+          <a:p>
+            <a:r>
+              <a:t>“Estas são as três decisões que diferenciam a MemeScript da BIRL-Lite. Primeiro, a atribuição começa com RECEBA: todo comando começa com uma palavra reservada própria, então o parser escolhe a produção olhando só o primeiro token. Segundo, as declarações ficam numa seção no início do programa e sempre têm valor inicial, então não existe variável sem valor. Terceiro, usamos terminadores diferentes: ATA fecha cada bloco e JA_ACABOU_JESSICA fecha o programa, enquanto a BIRL usa a mesma palavra para tudo.”</a:t>
+            </a:r>
+          </a:p>
+        </p:txBody>
+      </p:sp>
+      <p:sp>
+        <p:nvSpPr>
+          <p:cNvPr id="4" name="Slide Number Placeholder 3"/>
+          <p:cNvSpPr>
+            <a:spLocks noGrp="1"/>
+          </p:cNvSpPr>
+          <p:nvPr>
+            <p:ph type="sldNum" idx="5" sz="quarter"/>
+          </p:nvPr>
+        </p:nvSpPr>
+        <p:spPr/>
+      </p:sp>
+    </p:spTree>
+  </p:cSld>
+  <p:clrMapOvr>
+    <a:masterClrMapping/>
+  </p:clrMapOvr>
+</p:notes>
+</file>
+
+<file path=ppt/notesSlides/notesSlide16.xml><?xml version="1.0" encoding="utf-8"?>
+<p:notes xmlns:a="http://schemas.openxmlformats.org/drawingml/2006/main" xmlns:p="http://schemas.openxmlformats.org/presentationml/2006/main" xmlns:r="http://schemas.openxmlformats.org/officeDocument/2006/relationships">
+  <p:cSld>
+    <p:spTree>
+      <p:nvGrpSpPr>
+        <p:cNvPr id="1" name=""/>
+        <p:cNvGrpSpPr/>
+        <p:nvPr/>
+      </p:nvGrpSpPr>
+      <p:grpSpPr>
+        <a:xfrm>
+          <a:off x="0" y="0"/>
+          <a:ext cx="0" cy="0"/>
+          <a:chOff x="0" y="0"/>
+          <a:chExt cx="0" cy="0"/>
+        </a:xfrm>
+      </p:grpSpPr>
+      <p:sp>
+        <p:nvSpPr>
+          <p:cNvPr id="2" name="Slide Image Placeholder 1"/>
+          <p:cNvSpPr>
+            <a:spLocks noGrp="1"/>
+          </p:cNvSpPr>
+          <p:nvPr>
+            <p:ph type="sldImg" idx="2"/>
+          </p:nvPr>
+        </p:nvSpPr>
+        <p:spPr/>
+      </p:sp>
+      <p:sp>
+        <p:nvSpPr>
+          <p:cNvPr id="3" name="Notes Placeholder 2"/>
+          <p:cNvSpPr>
+            <a:spLocks noGrp="1"/>
+          </p:cNvSpPr>
+          <p:nvPr>
+            <p:ph type="body" idx="3" sz="quarter"/>
+          </p:nvPr>
+        </p:nvSpPr>
+        <p:spPr/>
+        <p:txBody>
+          <a:bodyPr/>
+          <a:lstStyle/>
+          <a:p>
+            <a:r>
+              <a:t>“O alfabeto Σ são os caracteres permitidos no código fora de textos e comentários. Cada categoria de token é descrita por uma expressão regular, então é uma linguagem regular. Palavras reservadas casam com o padrão de identificador e depois são separadas por uma tabela. Um caractere fora de Σ, como o @, gera erro léxico com linha e coluna, e a compilação para.”</a:t>
+            </a:r>
+          </a:p>
+        </p:txBody>
+      </p:sp>
+      <p:sp>
+        <p:nvSpPr>
+          <p:cNvPr id="4" name="Slide Number Placeholder 3"/>
+          <p:cNvSpPr>
+            <a:spLocks noGrp="1"/>
+          </p:cNvSpPr>
+          <p:nvPr>
+            <p:ph type="sldNum" idx="5" sz="quarter"/>
+          </p:nvPr>
+        </p:nvSpPr>
+        <p:spPr/>
+      </p:sp>
+    </p:spTree>
+  </p:cSld>
+  <p:clrMapOvr>
+    <a:masterClrMapping/>
+  </p:clrMapOvr>
+</p:notes>
+</file>
+
 <file path=ppt/notesSlides/notesSlide2.xml><?xml version="1.0" encoding="utf-8"?>
 <p:notes xmlns:p="http://schemas.openxmlformats.org/presentationml/2006/main">
   <p:cSld>
@@ -1381,6 +1523,15 @@
           <a:p xmlns:a="http://schemas.openxmlformats.org/drawingml/2006/main">
             <a:r>
               <a:t>Novos delimitadores: E_HORA_DO_SHOW inicia o programa e JA_ACABOU_JESSICA o encerra. Referências: https://33giga.com.br/e-hora-do-show-confira-memes-saidos-do-iconico-video-de-bambam-e-companhia ; https://museudememes.com.br/collection/ja-acabou-jessica .</a:t>
+            </a:r>
+            <a:endParaRPr/>
+          </a:p>
+          <a:p xmlns:a="http://schemas.openxmlformats.org/drawingml/2006/main">
+            <a:endParaRPr/>
+          </a:p>
+          <a:p xmlns:a="http://schemas.openxmlformats.org/drawingml/2006/main">
+            <a:r>
+              <a:t>G = (V, T, P, S): S = program; V tem 17 não-terminais (program, declaration, statement, expression...); T são as palavras reservadas, operadores, delimitadores e as categorias IDENTIFIER, INTEGER, REAL e STRING; P são as produções em EBNF. A indentação do código-fonte serve só para leitura: quem fecha os blocos é o ATA.</a:t>
             </a:r>
             <a:endParaRPr/>
           </a:p>
@@ -6943,7 +7094,7 @@
                   <a:schemeClr val="bg1"/>
                 </a:solidFill>
               </a:rPr>
-              <a:t>Decisões e limites</a:t>
+              <a:t>Resumo: decisões e limites</a:t>
             </a:r>
             <a:endParaRPr sz="4000"/>
           </a:p>
@@ -7760,6 +7911,2165 @@
     <p:extLst>
       <p:ext uri="{BB962C8B-B14F-4D97-AF65-F5344CB8AC3E}">
         <p14:creationId xmlns:p14="http://schemas.microsoft.com/office/powerpoint/2010/main" val="276962837"/>
+      </p:ext>
+    </p:extLst>
+  </p:cSld>
+</p:sld>
+</file>
+
+<file path=ppt/slides/slide15.xml><?xml version="1.0" encoding="utf-8"?>
+<p:sld xmlns:p="http://schemas.openxmlformats.org/presentationml/2006/main">
+  <p:cSld>
+    <p:spTree>
+      <p:nvGrpSpPr>
+        <p:cNvPr id="1" name=""/>
+        <p:cNvGrpSpPr/>
+        <p:nvPr/>
+      </p:nvGrpSpPr>
+      <p:grpSpPr>
+        <a:xfrm xmlns:a="http://schemas.openxmlformats.org/drawingml/2006/main"/>
+      </p:grpSpPr>
+      <p:sp>
+        <p:nvSpPr>
+          <p:cNvPr id="2" name="Text 0">
+            <a:extLst xmlns:a="http://schemas.openxmlformats.org/drawingml/2006/main">
+              <a:ext uri="{FF2B5EF4-FFF2-40B4-BE49-F238E27FC236}">
+                <a16:creationId xmlns:a16="http://schemas.microsoft.com/office/drawing/2014/main" id="{29B9C35A-F456-4CD4-B1EC-D4EE1D26A0CA}"/>
+              </a:ext>
+            </a:extLst>
+          </p:cNvPr>
+          <p:cNvSpPr>
+            <a:spLocks xmlns:a="http://schemas.openxmlformats.org/drawingml/2006/main" noGrp="1"/>
+          </p:cNvSpPr>
+          <p:nvPr>
+            <p:ph type="title" idx="100" hasCustomPrompt="1"/>
+          </p:nvPr>
+        </p:nvSpPr>
+        <p:spPr>
+          <a:xfrm xmlns:a="http://schemas.openxmlformats.org/drawingml/2006/main">
+            <a:off x="548640" y="365760"/>
+            <a:ext cx="11091672" cy="868680"/>
+          </a:xfrm>
+          <a:prstGeom xmlns:a="http://schemas.openxmlformats.org/drawingml/2006/main" prst="rect">
+            <a:avLst/>
+          </a:prstGeom>
+          <a:noFill xmlns:a="http://schemas.openxmlformats.org/drawingml/2006/main"/>
+        </p:spPr>
+        <p:txBody>
+          <a:bodyPr xmlns:a="http://schemas.openxmlformats.org/drawingml/2006/main" wrap="square" lIns="0" tIns="0" rIns="0" bIns="0" anchor="ctr"/>
+          <a:lstStyle xmlns:a="http://schemas.openxmlformats.org/drawingml/2006/main"/>
+          <a:p xmlns:a="http://schemas.openxmlformats.org/drawingml/2006/main">
+            <a:pPr marL="0" indent="0" algn="l">
+              <a:buNone/>
+            </a:pPr>
+            <a:r>
+              <a:rPr sz="4000">
+                <a:solidFill>
+                  <a:schemeClr val="tx1"/>
+                </a:solidFill>
+              </a:rPr>
+              <a:t>Decisões próprias de projeto</a:t>
+            </a:r>
+            <a:endParaRPr sz="4000"/>
+          </a:p>
+        </p:txBody>
+      </p:sp>
+      <p:sp>
+        <p:nvSpPr>
+          <p:cNvPr id="4" name="Cartão Léxico">
+            <a:extLst xmlns:a="http://schemas.openxmlformats.org/drawingml/2006/main">
+              <a:ext uri="{FF2B5EF4-FFF2-40B4-BE49-F238E27FC236}">
+                <a16:creationId xmlns:a16="http://schemas.microsoft.com/office/drawing/2014/main" id="{8AB4ECE9-24C0-4EC0-8F69-4D4FAB476D98}"/>
+              </a:ext>
+            </a:extLst>
+          </p:cNvPr>
+          <p:cNvSpPr>
+            <a:spLocks xmlns:a="http://schemas.openxmlformats.org/drawingml/2006/main" noGrp="1"/>
+          </p:cNvSpPr>
+          <p:nvPr/>
+        </p:nvSpPr>
+        <p:spPr>
+          <a:xfrm xmlns:a="http://schemas.openxmlformats.org/drawingml/2006/main">
+            <a:off x="548640" y="1508760"/>
+            <a:ext cx="3566160" cy="3063240"/>
+          </a:xfrm>
+          <a:prstGeom xmlns:a="http://schemas.openxmlformats.org/drawingml/2006/main" prst="roundRect">
+            <a:avLst>
+              <a:gd name="adj" fmla="val 4179"/>
+            </a:avLst>
+          </a:prstGeom>
+          <a:solidFill xmlns:a="http://schemas.openxmlformats.org/drawingml/2006/main">
+            <a:schemeClr val="bg1"/>
+          </a:solidFill>
+          <a:ln xmlns:a="http://schemas.openxmlformats.org/drawingml/2006/main" w="19050">
+            <a:solidFill>
+              <a:schemeClr val="tx1"/>
+            </a:solidFill>
+            <a:prstDash val="solid"/>
+          </a:ln>
+          <a:effectLst xmlns:a="http://schemas.openxmlformats.org/drawingml/2006/main">
+            <a:outerShdw blurRad="101600" dist="50800" dir="2700000" sx="100000" sy="100000" kx="0" ky="0" algn="bl" rotWithShape="0">
+              <a:srgbClr val="15121F">
+                <a:alpha val="100000"/>
+              </a:srgbClr>
+            </a:outerShdw>
+          </a:effectLst>
+        </p:spPr>
+      </p:sp>
+      <p:sp>
+        <p:nvSpPr>
+          <p:cNvPr id="5" name="Etiqueta Léxico">
+            <a:extLst xmlns:a="http://schemas.openxmlformats.org/drawingml/2006/main">
+              <a:ext uri="{FF2B5EF4-FFF2-40B4-BE49-F238E27FC236}">
+                <a16:creationId xmlns:a16="http://schemas.microsoft.com/office/drawing/2014/main" id="{39961549-4722-40F3-9C1D-80BA27D49633}"/>
+              </a:ext>
+            </a:extLst>
+          </p:cNvPr>
+          <p:cNvSpPr>
+            <a:spLocks xmlns:a="http://schemas.openxmlformats.org/drawingml/2006/main" noGrp="1"/>
+          </p:cNvSpPr>
+          <p:nvPr/>
+        </p:nvSpPr>
+        <p:spPr>
+          <a:xfrm xmlns:a="http://schemas.openxmlformats.org/drawingml/2006/main">
+            <a:off x="822960" y="1783080"/>
+            <a:ext cx="1737360" cy="502920"/>
+          </a:xfrm>
+          <a:prstGeom xmlns:a="http://schemas.openxmlformats.org/drawingml/2006/main" prst="roundRect">
+            <a:avLst>
+              <a:gd name="adj" fmla="val 21818"/>
+            </a:avLst>
+          </a:prstGeom>
+          <a:solidFill xmlns:a="http://schemas.openxmlformats.org/drawingml/2006/main">
+            <a:schemeClr val="accent1"/>
+          </a:solidFill>
+          <a:ln xmlns:a="http://schemas.openxmlformats.org/drawingml/2006/main" w="15875">
+            <a:solidFill>
+              <a:schemeClr val="tx1"/>
+            </a:solidFill>
+            <a:prstDash val="solid"/>
+          </a:ln>
+        </p:spPr>
+      </p:sp>
+      <p:sp>
+        <p:nvSpPr>
+          <p:cNvPr id="6" name="Categoria Léxico">
+            <a:extLst xmlns:a="http://schemas.openxmlformats.org/drawingml/2006/main">
+              <a:ext uri="{FF2B5EF4-FFF2-40B4-BE49-F238E27FC236}">
+                <a16:creationId xmlns:a16="http://schemas.microsoft.com/office/drawing/2014/main" id="{0967F698-4D86-4F83-B0BB-02A9E1C2CCB6}"/>
+              </a:ext>
+            </a:extLst>
+          </p:cNvPr>
+          <p:cNvSpPr>
+            <a:spLocks xmlns:a="http://schemas.openxmlformats.org/drawingml/2006/main" noGrp="1"/>
+          </p:cNvSpPr>
+          <p:nvPr/>
+        </p:nvSpPr>
+        <p:spPr>
+          <a:xfrm xmlns:a="http://schemas.openxmlformats.org/drawingml/2006/main">
+            <a:off x="822960" y="1783080"/>
+            <a:ext cx="1737360" cy="502920"/>
+          </a:xfrm>
+          <a:prstGeom xmlns:a="http://schemas.openxmlformats.org/drawingml/2006/main" prst="rect">
+            <a:avLst/>
+          </a:prstGeom>
+          <a:noFill xmlns:a="http://schemas.openxmlformats.org/drawingml/2006/main"/>
+        </p:spPr>
+        <p:txBody>
+          <a:bodyPr xmlns:a="http://schemas.openxmlformats.org/drawingml/2006/main" wrap="square" lIns="0" tIns="0" rIns="0" bIns="0" anchor="ctr"/>
+          <a:lstStyle xmlns:a="http://schemas.openxmlformats.org/drawingml/2006/main"/>
+          <a:p xmlns:a="http://schemas.openxmlformats.org/drawingml/2006/main">
+            <a:pPr marL="0" indent="0" algn="ctr">
+              <a:buNone/>
+            </a:pPr>
+            <a:r>
+              <a:rPr sz="1800" b="1">
+                <a:solidFill>
+                  <a:schemeClr val="tx1"/>
+                </a:solidFill>
+              </a:rPr>
+              <a:t>Atribuição</a:t>
+            </a:r>
+            <a:endParaRPr sz="1800"/>
+          </a:p>
+        </p:txBody>
+      </p:sp>
+      <p:sp>
+        <p:nvSpPr>
+          <p:cNvPr id="7" name="Legenda fonte Léxico">
+            <a:extLst xmlns:a="http://schemas.openxmlformats.org/drawingml/2006/main">
+              <a:ext uri="{FF2B5EF4-FFF2-40B4-BE49-F238E27FC236}">
+                <a16:creationId xmlns:a16="http://schemas.microsoft.com/office/drawing/2014/main" id="{62F6B494-4871-491D-AB54-712FAC0C47A5}"/>
+              </a:ext>
+            </a:extLst>
+          </p:cNvPr>
+          <p:cNvSpPr>
+            <a:spLocks xmlns:a="http://schemas.openxmlformats.org/drawingml/2006/main" noGrp="1"/>
+          </p:cNvSpPr>
+          <p:nvPr/>
+        </p:nvSpPr>
+        <p:spPr>
+          <a:xfrm xmlns:a="http://schemas.openxmlformats.org/drawingml/2006/main">
+            <a:off x="822960" y="2514600"/>
+            <a:ext cx="3017520" cy="274320"/>
+          </a:xfrm>
+          <a:prstGeom xmlns:a="http://schemas.openxmlformats.org/drawingml/2006/main" prst="rect">
+            <a:avLst/>
+          </a:prstGeom>
+          <a:noFill xmlns:a="http://schemas.openxmlformats.org/drawingml/2006/main"/>
+        </p:spPr>
+        <p:txBody>
+          <a:bodyPr xmlns:a="http://schemas.openxmlformats.org/drawingml/2006/main" wrap="square" lIns="0" tIns="0" rIns="0" bIns="0" anchor="ctr"/>
+          <a:lstStyle xmlns:a="http://schemas.openxmlformats.org/drawingml/2006/main"/>
+          <a:p xmlns:a="http://schemas.openxmlformats.org/drawingml/2006/main">
+            <a:pPr marL="0" indent="0">
+              <a:buNone/>
+            </a:pPr>
+            <a:r>
+              <a:rPr sz="1200">
+                <a:solidFill>
+                  <a:schemeClr val="tx2"/>
+                </a:solidFill>
+              </a:rPr>
+              <a:t>MemeScript</a:t>
+            </a:r>
+            <a:endParaRPr sz="1200"/>
+          </a:p>
+        </p:txBody>
+      </p:sp>
+      <p:sp>
+        <p:nvSpPr>
+          <p:cNvPr id="8" name="Caixa fonte Léxico">
+            <a:extLst xmlns:a="http://schemas.openxmlformats.org/drawingml/2006/main">
+              <a:ext uri="{FF2B5EF4-FFF2-40B4-BE49-F238E27FC236}">
+                <a16:creationId xmlns:a16="http://schemas.microsoft.com/office/drawing/2014/main" id="{816D8AF5-74C3-4664-9B34-3B9A11E8BBEA}"/>
+              </a:ext>
+            </a:extLst>
+          </p:cNvPr>
+          <p:cNvSpPr>
+            <a:spLocks xmlns:a="http://schemas.openxmlformats.org/drawingml/2006/main" noGrp="1"/>
+          </p:cNvSpPr>
+          <p:nvPr/>
+        </p:nvSpPr>
+        <p:spPr>
+          <a:xfrm xmlns:a="http://schemas.openxmlformats.org/drawingml/2006/main">
+            <a:off x="822960" y="2834640"/>
+            <a:ext cx="3017520" cy="640080"/>
+          </a:xfrm>
+          <a:prstGeom xmlns:a="http://schemas.openxmlformats.org/drawingml/2006/main" prst="roundRect">
+            <a:avLst>
+              <a:gd name="adj" fmla="val 14286"/>
+            </a:avLst>
+          </a:prstGeom>
+          <a:solidFill xmlns:a="http://schemas.openxmlformats.org/drawingml/2006/main">
+            <a:schemeClr val="tx1"/>
+          </a:solidFill>
+        </p:spPr>
+      </p:sp>
+      <p:sp>
+        <p:nvSpPr>
+          <p:cNvPr id="9" name="Fonte Léxico">
+            <a:extLst xmlns:a="http://schemas.openxmlformats.org/drawingml/2006/main">
+              <a:ext uri="{FF2B5EF4-FFF2-40B4-BE49-F238E27FC236}">
+                <a16:creationId xmlns:a16="http://schemas.microsoft.com/office/drawing/2014/main" id="{0068CD51-6DAE-4715-B0E7-2DFCAA00D4F1}"/>
+              </a:ext>
+            </a:extLst>
+          </p:cNvPr>
+          <p:cNvSpPr>
+            <a:spLocks xmlns:a="http://schemas.openxmlformats.org/drawingml/2006/main" noGrp="1"/>
+          </p:cNvSpPr>
+          <p:nvPr/>
+        </p:nvSpPr>
+        <p:spPr>
+          <a:xfrm xmlns:a="http://schemas.openxmlformats.org/drawingml/2006/main">
+            <a:off x="822960" y="2834640"/>
+            <a:ext cx="3017520" cy="640080"/>
+          </a:xfrm>
+          <a:prstGeom xmlns:a="http://schemas.openxmlformats.org/drawingml/2006/main" prst="rect">
+            <a:avLst/>
+          </a:prstGeom>
+          <a:noFill xmlns:a="http://schemas.openxmlformats.org/drawingml/2006/main"/>
+        </p:spPr>
+        <p:txBody>
+          <a:bodyPr xmlns:a="http://schemas.openxmlformats.org/drawingml/2006/main" wrap="square" lIns="0" tIns="0" rIns="0" bIns="0" anchor="ctr"/>
+          <a:lstStyle xmlns:a="http://schemas.openxmlformats.org/drawingml/2006/main"/>
+          <a:p xmlns:a="http://schemas.openxmlformats.org/drawingml/2006/main">
+            <a:pPr marL="0" indent="0" algn="ctr">
+              <a:buNone/>
+            </a:pPr>
+            <a:r>
+              <a:rPr sz="1600" b="1">
+                <a:solidFill>
+                  <a:schemeClr val="accent1"/>
+                </a:solidFill>
+                <a:latin typeface="Courier New"/>
+                <a:ea typeface="Courier New"/>
+                <a:cs typeface="Courier New"/>
+              </a:rPr>
+              <a:t>RECEBA</a:t>
+            </a:r>
+            <a:r>
+              <a:rPr sz="1600" b="1">
+                <a:solidFill>
+                  <a:schemeClr val="bg1"/>
+                </a:solidFill>
+                <a:latin typeface="Courier New"/>
+                <a:ea typeface="Courier New"/>
+                <a:cs typeface="Courier New"/>
+              </a:rPr>
+              <a:t> x = 2 + 3;</a:t>
+            </a:r>
+            <a:endParaRPr sz="1600"/>
+          </a:p>
+        </p:txBody>
+      </p:sp>
+      <p:sp>
+        <p:nvSpPr>
+          <p:cNvPr id="10" name="Legenda motivo Léxico">
+            <a:extLst xmlns:a="http://schemas.openxmlformats.org/drawingml/2006/main">
+              <a:ext uri="{FF2B5EF4-FFF2-40B4-BE49-F238E27FC236}">
+                <a16:creationId xmlns:a16="http://schemas.microsoft.com/office/drawing/2014/main" id="{2EEF5DEF-EDAC-4274-9CD9-00B87FCAE725}"/>
+              </a:ext>
+            </a:extLst>
+          </p:cNvPr>
+          <p:cNvSpPr>
+            <a:spLocks xmlns:a="http://schemas.openxmlformats.org/drawingml/2006/main" noGrp="1"/>
+          </p:cNvSpPr>
+          <p:nvPr/>
+        </p:nvSpPr>
+        <p:spPr>
+          <a:xfrm xmlns:a="http://schemas.openxmlformats.org/drawingml/2006/main">
+            <a:off x="822960" y="3703320"/>
+            <a:ext cx="3017520" cy="274320"/>
+          </a:xfrm>
+          <a:prstGeom xmlns:a="http://schemas.openxmlformats.org/drawingml/2006/main" prst="rect">
+            <a:avLst/>
+          </a:prstGeom>
+          <a:noFill xmlns:a="http://schemas.openxmlformats.org/drawingml/2006/main"/>
+        </p:spPr>
+        <p:txBody>
+          <a:bodyPr xmlns:a="http://schemas.openxmlformats.org/drawingml/2006/main" wrap="square" lIns="0" tIns="0" rIns="0" bIns="0" anchor="ctr"/>
+          <a:lstStyle xmlns:a="http://schemas.openxmlformats.org/drawingml/2006/main"/>
+          <a:p xmlns:a="http://schemas.openxmlformats.org/drawingml/2006/main">
+            <a:pPr marL="0" indent="0">
+              <a:buNone/>
+            </a:pPr>
+            <a:r>
+              <a:rPr sz="1200">
+                <a:solidFill>
+                  <a:schemeClr val="tx2"/>
+                </a:solidFill>
+              </a:rPr>
+              <a:t>BIRL-Lite: x = 2 + 3;</a:t>
+            </a:r>
+            <a:endParaRPr sz="1200"/>
+          </a:p>
+        </p:txBody>
+      </p:sp>
+      <p:sp>
+        <p:nvSpPr>
+          <p:cNvPr id="11" name="Motivo Léxico">
+            <a:extLst xmlns:a="http://schemas.openxmlformats.org/drawingml/2006/main">
+              <a:ext uri="{FF2B5EF4-FFF2-40B4-BE49-F238E27FC236}">
+                <a16:creationId xmlns:a16="http://schemas.microsoft.com/office/drawing/2014/main" id="{01CD8CEC-EAB9-4483-9C5B-A10055B0CAFC}"/>
+              </a:ext>
+            </a:extLst>
+          </p:cNvPr>
+          <p:cNvSpPr>
+            <a:spLocks xmlns:a="http://schemas.openxmlformats.org/drawingml/2006/main" noGrp="1"/>
+          </p:cNvSpPr>
+          <p:nvPr/>
+        </p:nvSpPr>
+        <p:spPr>
+          <a:xfrm xmlns:a="http://schemas.openxmlformats.org/drawingml/2006/main">
+            <a:off x="822960" y="3977640"/>
+            <a:ext cx="3017520" cy="411480"/>
+          </a:xfrm>
+          <a:prstGeom xmlns:a="http://schemas.openxmlformats.org/drawingml/2006/main" prst="rect">
+            <a:avLst/>
+          </a:prstGeom>
+          <a:noFill xmlns:a="http://schemas.openxmlformats.org/drawingml/2006/main"/>
+        </p:spPr>
+        <p:txBody>
+          <a:bodyPr xmlns:a="http://schemas.openxmlformats.org/drawingml/2006/main" wrap="square" lIns="0" tIns="0" rIns="0" bIns="0" anchor="ctr"/>
+          <a:lstStyle xmlns:a="http://schemas.openxmlformats.org/drawingml/2006/main"/>
+          <a:p xmlns:a="http://schemas.openxmlformats.org/drawingml/2006/main">
+            <a:pPr marL="0" indent="0">
+              <a:buNone/>
+            </a:pPr>
+            <a:r>
+              <a:rPr sz="2000" b="1">
+                <a:solidFill>
+                  <a:schemeClr val="tx1"/>
+                </a:solidFill>
+              </a:rPr>
+              <a:t>Decide pelo 1º token</a:t>
+            </a:r>
+            <a:endParaRPr sz="2000"/>
+          </a:p>
+        </p:txBody>
+      </p:sp>
+      <p:sp>
+        <p:nvSpPr>
+          <p:cNvPr id="12" name="Cartão Sintático">
+            <a:extLst xmlns:a="http://schemas.openxmlformats.org/drawingml/2006/main">
+              <a:ext uri="{FF2B5EF4-FFF2-40B4-BE49-F238E27FC236}">
+                <a16:creationId xmlns:a16="http://schemas.microsoft.com/office/drawing/2014/main" id="{CD3CF58B-28CE-4F94-9920-89F789F83743}"/>
+              </a:ext>
+            </a:extLst>
+          </p:cNvPr>
+          <p:cNvSpPr>
+            <a:spLocks xmlns:a="http://schemas.openxmlformats.org/drawingml/2006/main" noGrp="1"/>
+          </p:cNvSpPr>
+          <p:nvPr/>
+        </p:nvSpPr>
+        <p:spPr>
+          <a:xfrm xmlns:a="http://schemas.openxmlformats.org/drawingml/2006/main">
+            <a:off x="4311396" y="1508760"/>
+            <a:ext cx="3566160" cy="3063240"/>
+          </a:xfrm>
+          <a:prstGeom xmlns:a="http://schemas.openxmlformats.org/drawingml/2006/main" prst="roundRect">
+            <a:avLst>
+              <a:gd name="adj" fmla="val 4179"/>
+            </a:avLst>
+          </a:prstGeom>
+          <a:solidFill xmlns:a="http://schemas.openxmlformats.org/drawingml/2006/main">
+            <a:schemeClr val="bg1"/>
+          </a:solidFill>
+          <a:ln xmlns:a="http://schemas.openxmlformats.org/drawingml/2006/main" w="19050">
+            <a:solidFill>
+              <a:schemeClr val="tx1"/>
+            </a:solidFill>
+            <a:prstDash val="solid"/>
+          </a:ln>
+          <a:effectLst xmlns:a="http://schemas.openxmlformats.org/drawingml/2006/main">
+            <a:outerShdw blurRad="101600" dist="50800" dir="2700000" sx="100000" sy="100000" kx="0" ky="0" algn="bl" rotWithShape="0">
+              <a:srgbClr val="15121F">
+                <a:alpha val="100000"/>
+              </a:srgbClr>
+            </a:outerShdw>
+          </a:effectLst>
+        </p:spPr>
+      </p:sp>
+      <p:sp>
+        <p:nvSpPr>
+          <p:cNvPr id="13" name="Etiqueta Sintático">
+            <a:extLst xmlns:a="http://schemas.openxmlformats.org/drawingml/2006/main">
+              <a:ext uri="{FF2B5EF4-FFF2-40B4-BE49-F238E27FC236}">
+                <a16:creationId xmlns:a16="http://schemas.microsoft.com/office/drawing/2014/main" id="{783AE385-0F7A-47A5-8604-86447889C9FB}"/>
+              </a:ext>
+            </a:extLst>
+          </p:cNvPr>
+          <p:cNvSpPr>
+            <a:spLocks xmlns:a="http://schemas.openxmlformats.org/drawingml/2006/main" noGrp="1"/>
+          </p:cNvSpPr>
+          <p:nvPr/>
+        </p:nvSpPr>
+        <p:spPr>
+          <a:xfrm xmlns:a="http://schemas.openxmlformats.org/drawingml/2006/main">
+            <a:off x="4585716" y="1783080"/>
+            <a:ext cx="1737360" cy="502920"/>
+          </a:xfrm>
+          <a:prstGeom xmlns:a="http://schemas.openxmlformats.org/drawingml/2006/main" prst="roundRect">
+            <a:avLst>
+              <a:gd name="adj" fmla="val 21818"/>
+            </a:avLst>
+          </a:prstGeom>
+          <a:solidFill xmlns:a="http://schemas.openxmlformats.org/drawingml/2006/main">
+            <a:schemeClr val="accent2"/>
+          </a:solidFill>
+          <a:ln xmlns:a="http://schemas.openxmlformats.org/drawingml/2006/main" w="15875">
+            <a:solidFill>
+              <a:schemeClr val="tx1"/>
+            </a:solidFill>
+            <a:prstDash val="solid"/>
+          </a:ln>
+        </p:spPr>
+      </p:sp>
+      <p:sp>
+        <p:nvSpPr>
+          <p:cNvPr id="14" name="Categoria Sintático">
+            <a:extLst xmlns:a="http://schemas.openxmlformats.org/drawingml/2006/main">
+              <a:ext uri="{FF2B5EF4-FFF2-40B4-BE49-F238E27FC236}">
+                <a16:creationId xmlns:a16="http://schemas.microsoft.com/office/drawing/2014/main" id="{02B36546-040E-41B8-BF70-76AE66896D3B}"/>
+              </a:ext>
+            </a:extLst>
+          </p:cNvPr>
+          <p:cNvSpPr>
+            <a:spLocks xmlns:a="http://schemas.openxmlformats.org/drawingml/2006/main" noGrp="1"/>
+          </p:cNvSpPr>
+          <p:nvPr/>
+        </p:nvSpPr>
+        <p:spPr>
+          <a:xfrm xmlns:a="http://schemas.openxmlformats.org/drawingml/2006/main">
+            <a:off x="4585716" y="1783080"/>
+            <a:ext cx="1737360" cy="502920"/>
+          </a:xfrm>
+          <a:prstGeom xmlns:a="http://schemas.openxmlformats.org/drawingml/2006/main" prst="rect">
+            <a:avLst/>
+          </a:prstGeom>
+          <a:noFill xmlns:a="http://schemas.openxmlformats.org/drawingml/2006/main"/>
+        </p:spPr>
+        <p:txBody>
+          <a:bodyPr xmlns:a="http://schemas.openxmlformats.org/drawingml/2006/main" wrap="square" lIns="0" tIns="0" rIns="0" bIns="0" anchor="ctr"/>
+          <a:lstStyle xmlns:a="http://schemas.openxmlformats.org/drawingml/2006/main"/>
+          <a:p xmlns:a="http://schemas.openxmlformats.org/drawingml/2006/main">
+            <a:pPr marL="0" indent="0" algn="ctr">
+              <a:buNone/>
+            </a:pPr>
+            <a:r>
+              <a:rPr sz="1800" b="1">
+                <a:solidFill>
+                  <a:schemeClr val="tx1"/>
+                </a:solidFill>
+              </a:rPr>
+              <a:t>Declarações</a:t>
+            </a:r>
+            <a:endParaRPr sz="1800"/>
+          </a:p>
+        </p:txBody>
+      </p:sp>
+      <p:sp>
+        <p:nvSpPr>
+          <p:cNvPr id="15" name="Legenda fonte Sintático">
+            <a:extLst xmlns:a="http://schemas.openxmlformats.org/drawingml/2006/main">
+              <a:ext uri="{FF2B5EF4-FFF2-40B4-BE49-F238E27FC236}">
+                <a16:creationId xmlns:a16="http://schemas.microsoft.com/office/drawing/2014/main" id="{C8BFB540-6286-4A69-B4E6-ADD53E82D45F}"/>
+              </a:ext>
+            </a:extLst>
+          </p:cNvPr>
+          <p:cNvSpPr>
+            <a:spLocks xmlns:a="http://schemas.openxmlformats.org/drawingml/2006/main" noGrp="1"/>
+          </p:cNvSpPr>
+          <p:nvPr/>
+        </p:nvSpPr>
+        <p:spPr>
+          <a:xfrm xmlns:a="http://schemas.openxmlformats.org/drawingml/2006/main">
+            <a:off x="4585716" y="2514600"/>
+            <a:ext cx="3017520" cy="274320"/>
+          </a:xfrm>
+          <a:prstGeom xmlns:a="http://schemas.openxmlformats.org/drawingml/2006/main" prst="rect">
+            <a:avLst/>
+          </a:prstGeom>
+          <a:noFill xmlns:a="http://schemas.openxmlformats.org/drawingml/2006/main"/>
+        </p:spPr>
+        <p:txBody>
+          <a:bodyPr xmlns:a="http://schemas.openxmlformats.org/drawingml/2006/main" wrap="square" lIns="0" tIns="0" rIns="0" bIns="0" anchor="ctr"/>
+          <a:lstStyle xmlns:a="http://schemas.openxmlformats.org/drawingml/2006/main"/>
+          <a:p xmlns:a="http://schemas.openxmlformats.org/drawingml/2006/main">
+            <a:pPr marL="0" indent="0">
+              <a:buNone/>
+            </a:pPr>
+            <a:r>
+              <a:rPr sz="1200">
+                <a:solidFill>
+                  <a:schemeClr val="tx2"/>
+                </a:solidFill>
+              </a:rPr>
+              <a:t>MemeScript</a:t>
+            </a:r>
+            <a:endParaRPr sz="1200"/>
+          </a:p>
+        </p:txBody>
+      </p:sp>
+      <p:sp>
+        <p:nvSpPr>
+          <p:cNvPr id="16" name="Caixa fonte Sintático">
+            <a:extLst xmlns:a="http://schemas.openxmlformats.org/drawingml/2006/main">
+              <a:ext uri="{FF2B5EF4-FFF2-40B4-BE49-F238E27FC236}">
+                <a16:creationId xmlns:a16="http://schemas.microsoft.com/office/drawing/2014/main" id="{E89D5CF5-A6D5-4785-ABA1-33759A5F90B8}"/>
+              </a:ext>
+            </a:extLst>
+          </p:cNvPr>
+          <p:cNvSpPr>
+            <a:spLocks xmlns:a="http://schemas.openxmlformats.org/drawingml/2006/main" noGrp="1"/>
+          </p:cNvSpPr>
+          <p:nvPr/>
+        </p:nvSpPr>
+        <p:spPr>
+          <a:xfrm xmlns:a="http://schemas.openxmlformats.org/drawingml/2006/main">
+            <a:off x="4585716" y="2834640"/>
+            <a:ext cx="3017520" cy="640080"/>
+          </a:xfrm>
+          <a:prstGeom xmlns:a="http://schemas.openxmlformats.org/drawingml/2006/main" prst="roundRect">
+            <a:avLst>
+              <a:gd name="adj" fmla="val 14286"/>
+            </a:avLst>
+          </a:prstGeom>
+          <a:solidFill xmlns:a="http://schemas.openxmlformats.org/drawingml/2006/main">
+            <a:schemeClr val="tx1"/>
+          </a:solidFill>
+        </p:spPr>
+      </p:sp>
+      <p:sp>
+        <p:nvSpPr>
+          <p:cNvPr id="17" name="Fonte Sintático">
+            <a:extLst xmlns:a="http://schemas.openxmlformats.org/drawingml/2006/main">
+              <a:ext uri="{FF2B5EF4-FFF2-40B4-BE49-F238E27FC236}">
+                <a16:creationId xmlns:a16="http://schemas.microsoft.com/office/drawing/2014/main" id="{C815AECF-BBB4-4B96-B066-BF842F05102A}"/>
+              </a:ext>
+            </a:extLst>
+          </p:cNvPr>
+          <p:cNvSpPr>
+            <a:spLocks xmlns:a="http://schemas.openxmlformats.org/drawingml/2006/main" noGrp="1"/>
+          </p:cNvSpPr>
+          <p:nvPr/>
+        </p:nvSpPr>
+        <p:spPr>
+          <a:xfrm xmlns:a="http://schemas.openxmlformats.org/drawingml/2006/main">
+            <a:off x="4585716" y="2834640"/>
+            <a:ext cx="3017520" cy="640080"/>
+          </a:xfrm>
+          <a:prstGeom xmlns:a="http://schemas.openxmlformats.org/drawingml/2006/main" prst="rect">
+            <a:avLst/>
+          </a:prstGeom>
+          <a:noFill xmlns:a="http://schemas.openxmlformats.org/drawingml/2006/main"/>
+        </p:spPr>
+        <p:txBody>
+          <a:bodyPr xmlns:a="http://schemas.openxmlformats.org/drawingml/2006/main" wrap="square" lIns="0" tIns="0" rIns="0" bIns="0" anchor="ctr"/>
+          <a:lstStyle xmlns:a="http://schemas.openxmlformats.org/drawingml/2006/main"/>
+          <a:p xmlns:a="http://schemas.openxmlformats.org/drawingml/2006/main">
+            <a:pPr marL="0" indent="0" algn="ctr">
+              <a:buNone/>
+            </a:pPr>
+            <a:r>
+              <a:rPr sz="1600" b="1">
+                <a:solidFill>
+                  <a:schemeClr val="accent1"/>
+                </a:solidFill>
+                <a:latin typeface="Courier New"/>
+                <a:ea typeface="Courier New"/>
+                <a:cs typeface="Courier New"/>
+              </a:rPr>
+              <a:t>SABOR_INTEIRO</a:t>
+            </a:r>
+            <a:r>
+              <a:rPr sz="1600" b="1">
+                <a:solidFill>
+                  <a:schemeClr val="bg1"/>
+                </a:solidFill>
+                <a:latin typeface="Courier New"/>
+                <a:ea typeface="Courier New"/>
+                <a:cs typeface="Courier New"/>
+              </a:rPr>
+              <a:t> x = 0;</a:t>
+            </a:r>
+            <a:endParaRPr sz="1600"/>
+          </a:p>
+        </p:txBody>
+      </p:sp>
+      <p:sp>
+        <p:nvSpPr>
+          <p:cNvPr id="18" name="Legenda motivo Sintático">
+            <a:extLst xmlns:a="http://schemas.openxmlformats.org/drawingml/2006/main">
+              <a:ext uri="{FF2B5EF4-FFF2-40B4-BE49-F238E27FC236}">
+                <a16:creationId xmlns:a16="http://schemas.microsoft.com/office/drawing/2014/main" id="{6D8DD24A-7EA4-4E96-94DE-2FD2CBB806BD}"/>
+              </a:ext>
+            </a:extLst>
+          </p:cNvPr>
+          <p:cNvSpPr>
+            <a:spLocks xmlns:a="http://schemas.openxmlformats.org/drawingml/2006/main" noGrp="1"/>
+          </p:cNvSpPr>
+          <p:nvPr/>
+        </p:nvSpPr>
+        <p:spPr>
+          <a:xfrm xmlns:a="http://schemas.openxmlformats.org/drawingml/2006/main">
+            <a:off x="4585716" y="3703320"/>
+            <a:ext cx="3017520" cy="274320"/>
+          </a:xfrm>
+          <a:prstGeom xmlns:a="http://schemas.openxmlformats.org/drawingml/2006/main" prst="rect">
+            <a:avLst/>
+          </a:prstGeom>
+          <a:noFill xmlns:a="http://schemas.openxmlformats.org/drawingml/2006/main"/>
+        </p:spPr>
+        <p:txBody>
+          <a:bodyPr xmlns:a="http://schemas.openxmlformats.org/drawingml/2006/main" wrap="square" lIns="0" tIns="0" rIns="0" bIns="0" anchor="ctr"/>
+          <a:lstStyle xmlns:a="http://schemas.openxmlformats.org/drawingml/2006/main"/>
+          <a:p xmlns:a="http://schemas.openxmlformats.org/drawingml/2006/main">
+            <a:pPr marL="0" indent="0">
+              <a:buNone/>
+            </a:pPr>
+            <a:r>
+              <a:rPr sz="1200">
+                <a:solidFill>
+                  <a:schemeClr val="tx2"/>
+                </a:solidFill>
+              </a:rPr>
+              <a:t>BIRL-Lite: misturadas, valor opcional</a:t>
+            </a:r>
+            <a:endParaRPr sz="1200"/>
+          </a:p>
+        </p:txBody>
+      </p:sp>
+      <p:sp>
+        <p:nvSpPr>
+          <p:cNvPr id="19" name="Motivo Sintático">
+            <a:extLst xmlns:a="http://schemas.openxmlformats.org/drawingml/2006/main">
+              <a:ext uri="{FF2B5EF4-FFF2-40B4-BE49-F238E27FC236}">
+                <a16:creationId xmlns:a16="http://schemas.microsoft.com/office/drawing/2014/main" id="{9C05BB2E-5652-47C9-90D6-40177D377580}"/>
+              </a:ext>
+            </a:extLst>
+          </p:cNvPr>
+          <p:cNvSpPr>
+            <a:spLocks xmlns:a="http://schemas.openxmlformats.org/drawingml/2006/main" noGrp="1"/>
+          </p:cNvSpPr>
+          <p:nvPr/>
+        </p:nvSpPr>
+        <p:spPr>
+          <a:xfrm xmlns:a="http://schemas.openxmlformats.org/drawingml/2006/main">
+            <a:off x="4585716" y="3977640"/>
+            <a:ext cx="3017520" cy="411480"/>
+          </a:xfrm>
+          <a:prstGeom xmlns:a="http://schemas.openxmlformats.org/drawingml/2006/main" prst="rect">
+            <a:avLst/>
+          </a:prstGeom>
+          <a:noFill xmlns:a="http://schemas.openxmlformats.org/drawingml/2006/main"/>
+        </p:spPr>
+        <p:txBody>
+          <a:bodyPr xmlns:a="http://schemas.openxmlformats.org/drawingml/2006/main" wrap="square" lIns="0" tIns="0" rIns="0" bIns="0" anchor="ctr"/>
+          <a:lstStyle xmlns:a="http://schemas.openxmlformats.org/drawingml/2006/main"/>
+          <a:p xmlns:a="http://schemas.openxmlformats.org/drawingml/2006/main">
+            <a:pPr marL="0" indent="0">
+              <a:buNone/>
+            </a:pPr>
+            <a:r>
+              <a:rPr sz="2000" b="1">
+                <a:solidFill>
+                  <a:schemeClr val="tx1"/>
+                </a:solidFill>
+              </a:rPr>
+              <a:t>Início e com valor</a:t>
+            </a:r>
+            <a:endParaRPr sz="2000"/>
+          </a:p>
+        </p:txBody>
+      </p:sp>
+      <p:sp>
+        <p:nvSpPr>
+          <p:cNvPr id="20" name="Cartão Semântico">
+            <a:extLst xmlns:a="http://schemas.openxmlformats.org/drawingml/2006/main">
+              <a:ext uri="{FF2B5EF4-FFF2-40B4-BE49-F238E27FC236}">
+                <a16:creationId xmlns:a16="http://schemas.microsoft.com/office/drawing/2014/main" id="{D35002FB-89BE-440A-A0AB-87EFC5DBE016}"/>
+              </a:ext>
+            </a:extLst>
+          </p:cNvPr>
+          <p:cNvSpPr>
+            <a:spLocks xmlns:a="http://schemas.openxmlformats.org/drawingml/2006/main" noGrp="1"/>
+          </p:cNvSpPr>
+          <p:nvPr/>
+        </p:nvSpPr>
+        <p:spPr>
+          <a:xfrm xmlns:a="http://schemas.openxmlformats.org/drawingml/2006/main">
+            <a:off x="8074152" y="1508760"/>
+            <a:ext cx="3566160" cy="3063240"/>
+          </a:xfrm>
+          <a:prstGeom xmlns:a="http://schemas.openxmlformats.org/drawingml/2006/main" prst="roundRect">
+            <a:avLst>
+              <a:gd name="adj" fmla="val 4179"/>
+            </a:avLst>
+          </a:prstGeom>
+          <a:solidFill xmlns:a="http://schemas.openxmlformats.org/drawingml/2006/main">
+            <a:schemeClr val="bg1"/>
+          </a:solidFill>
+          <a:ln xmlns:a="http://schemas.openxmlformats.org/drawingml/2006/main" w="19050">
+            <a:solidFill>
+              <a:schemeClr val="tx1"/>
+            </a:solidFill>
+            <a:prstDash val="solid"/>
+          </a:ln>
+          <a:effectLst xmlns:a="http://schemas.openxmlformats.org/drawingml/2006/main">
+            <a:outerShdw blurRad="101600" dist="50800" dir="2700000" sx="100000" sy="100000" kx="0" ky="0" algn="bl" rotWithShape="0">
+              <a:srgbClr val="15121F">
+                <a:alpha val="100000"/>
+              </a:srgbClr>
+            </a:outerShdw>
+          </a:effectLst>
+        </p:spPr>
+      </p:sp>
+      <p:sp>
+        <p:nvSpPr>
+          <p:cNvPr id="21" name="Etiqueta Semântico">
+            <a:extLst xmlns:a="http://schemas.openxmlformats.org/drawingml/2006/main">
+              <a:ext uri="{FF2B5EF4-FFF2-40B4-BE49-F238E27FC236}">
+                <a16:creationId xmlns:a16="http://schemas.microsoft.com/office/drawing/2014/main" id="{15C929ED-72B7-4423-8F88-21BA7B440C98}"/>
+              </a:ext>
+            </a:extLst>
+          </p:cNvPr>
+          <p:cNvSpPr>
+            <a:spLocks xmlns:a="http://schemas.openxmlformats.org/drawingml/2006/main" noGrp="1"/>
+          </p:cNvSpPr>
+          <p:nvPr/>
+        </p:nvSpPr>
+        <p:spPr>
+          <a:xfrm xmlns:a="http://schemas.openxmlformats.org/drawingml/2006/main">
+            <a:off x="8348472" y="1783080"/>
+            <a:ext cx="1737360" cy="502920"/>
+          </a:xfrm>
+          <a:prstGeom xmlns:a="http://schemas.openxmlformats.org/drawingml/2006/main" prst="roundRect">
+            <a:avLst>
+              <a:gd name="adj" fmla="val 21818"/>
+            </a:avLst>
+          </a:prstGeom>
+          <a:solidFill xmlns:a="http://schemas.openxmlformats.org/drawingml/2006/main">
+            <a:schemeClr val="accent3"/>
+          </a:solidFill>
+          <a:ln xmlns:a="http://schemas.openxmlformats.org/drawingml/2006/main" w="15875">
+            <a:solidFill>
+              <a:schemeClr val="tx1"/>
+            </a:solidFill>
+            <a:prstDash val="solid"/>
+          </a:ln>
+        </p:spPr>
+      </p:sp>
+      <p:sp>
+        <p:nvSpPr>
+          <p:cNvPr id="22" name="Categoria Semântico">
+            <a:extLst xmlns:a="http://schemas.openxmlformats.org/drawingml/2006/main">
+              <a:ext uri="{FF2B5EF4-FFF2-40B4-BE49-F238E27FC236}">
+                <a16:creationId xmlns:a16="http://schemas.microsoft.com/office/drawing/2014/main" id="{251FEDAC-0F22-4356-8E45-F9500102D68A}"/>
+              </a:ext>
+            </a:extLst>
+          </p:cNvPr>
+          <p:cNvSpPr>
+            <a:spLocks xmlns:a="http://schemas.openxmlformats.org/drawingml/2006/main" noGrp="1"/>
+          </p:cNvSpPr>
+          <p:nvPr/>
+        </p:nvSpPr>
+        <p:spPr>
+          <a:xfrm xmlns:a="http://schemas.openxmlformats.org/drawingml/2006/main">
+            <a:off x="8348472" y="1783080"/>
+            <a:ext cx="1737360" cy="502920"/>
+          </a:xfrm>
+          <a:prstGeom xmlns:a="http://schemas.openxmlformats.org/drawingml/2006/main" prst="rect">
+            <a:avLst/>
+          </a:prstGeom>
+          <a:noFill xmlns:a="http://schemas.openxmlformats.org/drawingml/2006/main"/>
+        </p:spPr>
+        <p:txBody>
+          <a:bodyPr xmlns:a="http://schemas.openxmlformats.org/drawingml/2006/main" wrap="square" lIns="0" tIns="0" rIns="0" bIns="0" anchor="ctr"/>
+          <a:lstStyle xmlns:a="http://schemas.openxmlformats.org/drawingml/2006/main"/>
+          <a:p xmlns:a="http://schemas.openxmlformats.org/drawingml/2006/main">
+            <a:pPr marL="0" indent="0" algn="ctr">
+              <a:buNone/>
+            </a:pPr>
+            <a:r>
+              <a:rPr sz="1800" b="1">
+                <a:solidFill>
+                  <a:schemeClr val="bg1"/>
+                </a:solidFill>
+              </a:rPr>
+              <a:t>Fechamento</a:t>
+            </a:r>
+            <a:endParaRPr sz="1800"/>
+          </a:p>
+        </p:txBody>
+      </p:sp>
+      <p:sp>
+        <p:nvSpPr>
+          <p:cNvPr id="23" name="Legenda fonte Semântico">
+            <a:extLst xmlns:a="http://schemas.openxmlformats.org/drawingml/2006/main">
+              <a:ext uri="{FF2B5EF4-FFF2-40B4-BE49-F238E27FC236}">
+                <a16:creationId xmlns:a16="http://schemas.microsoft.com/office/drawing/2014/main" id="{02E36126-74F7-48C4-A92C-426A78204585}"/>
+              </a:ext>
+            </a:extLst>
+          </p:cNvPr>
+          <p:cNvSpPr>
+            <a:spLocks xmlns:a="http://schemas.openxmlformats.org/drawingml/2006/main" noGrp="1"/>
+          </p:cNvSpPr>
+          <p:nvPr/>
+        </p:nvSpPr>
+        <p:spPr>
+          <a:xfrm xmlns:a="http://schemas.openxmlformats.org/drawingml/2006/main">
+            <a:off x="8348472" y="2514600"/>
+            <a:ext cx="3017520" cy="274320"/>
+          </a:xfrm>
+          <a:prstGeom xmlns:a="http://schemas.openxmlformats.org/drawingml/2006/main" prst="rect">
+            <a:avLst/>
+          </a:prstGeom>
+          <a:noFill xmlns:a="http://schemas.openxmlformats.org/drawingml/2006/main"/>
+        </p:spPr>
+        <p:txBody>
+          <a:bodyPr xmlns:a="http://schemas.openxmlformats.org/drawingml/2006/main" wrap="square" lIns="0" tIns="0" rIns="0" bIns="0" anchor="ctr"/>
+          <a:lstStyle xmlns:a="http://schemas.openxmlformats.org/drawingml/2006/main"/>
+          <a:p xmlns:a="http://schemas.openxmlformats.org/drawingml/2006/main">
+            <a:pPr marL="0" indent="0">
+              <a:buNone/>
+            </a:pPr>
+            <a:r>
+              <a:rPr sz="1200">
+                <a:solidFill>
+                  <a:schemeClr val="tx2"/>
+                </a:solidFill>
+              </a:rPr>
+              <a:t>MemeScript</a:t>
+            </a:r>
+            <a:endParaRPr sz="1200"/>
+          </a:p>
+        </p:txBody>
+      </p:sp>
+      <p:sp>
+        <p:nvSpPr>
+          <p:cNvPr id="24" name="Caixa fonte Semântico">
+            <a:extLst xmlns:a="http://schemas.openxmlformats.org/drawingml/2006/main">
+              <a:ext uri="{FF2B5EF4-FFF2-40B4-BE49-F238E27FC236}">
+                <a16:creationId xmlns:a16="http://schemas.microsoft.com/office/drawing/2014/main" id="{CC9E5094-F348-4DFF-9D8D-BF173D77E46B}"/>
+              </a:ext>
+            </a:extLst>
+          </p:cNvPr>
+          <p:cNvSpPr>
+            <a:spLocks xmlns:a="http://schemas.openxmlformats.org/drawingml/2006/main" noGrp="1"/>
+          </p:cNvSpPr>
+          <p:nvPr/>
+        </p:nvSpPr>
+        <p:spPr>
+          <a:xfrm xmlns:a="http://schemas.openxmlformats.org/drawingml/2006/main">
+            <a:off x="8348472" y="2834640"/>
+            <a:ext cx="3017520" cy="640080"/>
+          </a:xfrm>
+          <a:prstGeom xmlns:a="http://schemas.openxmlformats.org/drawingml/2006/main" prst="roundRect">
+            <a:avLst>
+              <a:gd name="adj" fmla="val 14286"/>
+            </a:avLst>
+          </a:prstGeom>
+          <a:solidFill xmlns:a="http://schemas.openxmlformats.org/drawingml/2006/main">
+            <a:schemeClr val="tx1"/>
+          </a:solidFill>
+        </p:spPr>
+      </p:sp>
+      <p:sp>
+        <p:nvSpPr>
+          <p:cNvPr id="25" name="Fonte Semântico">
+            <a:extLst xmlns:a="http://schemas.openxmlformats.org/drawingml/2006/main">
+              <a:ext uri="{FF2B5EF4-FFF2-40B4-BE49-F238E27FC236}">
+                <a16:creationId xmlns:a16="http://schemas.microsoft.com/office/drawing/2014/main" id="{459C4CD5-931B-4F2F-BBC6-228252319CCD}"/>
+              </a:ext>
+            </a:extLst>
+          </p:cNvPr>
+          <p:cNvSpPr>
+            <a:spLocks xmlns:a="http://schemas.openxmlformats.org/drawingml/2006/main" noGrp="1"/>
+          </p:cNvSpPr>
+          <p:nvPr/>
+        </p:nvSpPr>
+        <p:spPr>
+          <a:xfrm xmlns:a="http://schemas.openxmlformats.org/drawingml/2006/main">
+            <a:off x="8348472" y="2834640"/>
+            <a:ext cx="3017520" cy="640080"/>
+          </a:xfrm>
+          <a:prstGeom xmlns:a="http://schemas.openxmlformats.org/drawingml/2006/main" prst="rect">
+            <a:avLst/>
+          </a:prstGeom>
+          <a:noFill xmlns:a="http://schemas.openxmlformats.org/drawingml/2006/main"/>
+        </p:spPr>
+        <p:txBody>
+          <a:bodyPr xmlns:a="http://schemas.openxmlformats.org/drawingml/2006/main" wrap="square" lIns="0" tIns="0" rIns="0" bIns="0" anchor="ctr"/>
+          <a:lstStyle xmlns:a="http://schemas.openxmlformats.org/drawingml/2006/main"/>
+          <a:p xmlns:a="http://schemas.openxmlformats.org/drawingml/2006/main">
+            <a:pPr marL="0" indent="0" algn="ctr">
+              <a:buNone/>
+            </a:pPr>
+            <a:r>
+              <a:rPr sz="1600" b="1">
+                <a:solidFill>
+                  <a:schemeClr val="accent1"/>
+                </a:solidFill>
+                <a:latin typeface="Courier New"/>
+                <a:ea typeface="Courier New"/>
+                <a:cs typeface="Courier New"/>
+              </a:rPr>
+              <a:t>ATA</a:t>
+            </a:r>
+            <a:r>
+              <a:rPr sz="1600" b="1">
+                <a:solidFill>
+                  <a:schemeClr val="bg1"/>
+                </a:solidFill>
+                <a:latin typeface="Courier New"/>
+                <a:ea typeface="Courier New"/>
+                <a:cs typeface="Courier New"/>
+              </a:rPr>
+              <a:t> · JA_ACABOU_JESSICA</a:t>
+            </a:r>
+            <a:endParaRPr sz="1600"/>
+          </a:p>
+        </p:txBody>
+      </p:sp>
+      <p:sp>
+        <p:nvSpPr>
+          <p:cNvPr id="26" name="Legenda motivo Semântico">
+            <a:extLst xmlns:a="http://schemas.openxmlformats.org/drawingml/2006/main">
+              <a:ext uri="{FF2B5EF4-FFF2-40B4-BE49-F238E27FC236}">
+                <a16:creationId xmlns:a16="http://schemas.microsoft.com/office/drawing/2014/main" id="{C1E540C9-FEE3-4F0B-877C-E7005D1D4CC8}"/>
+              </a:ext>
+            </a:extLst>
+          </p:cNvPr>
+          <p:cNvSpPr>
+            <a:spLocks xmlns:a="http://schemas.openxmlformats.org/drawingml/2006/main" noGrp="1"/>
+          </p:cNvSpPr>
+          <p:nvPr/>
+        </p:nvSpPr>
+        <p:spPr>
+          <a:xfrm xmlns:a="http://schemas.openxmlformats.org/drawingml/2006/main">
+            <a:off x="8348472" y="3703320"/>
+            <a:ext cx="3017520" cy="274320"/>
+          </a:xfrm>
+          <a:prstGeom xmlns:a="http://schemas.openxmlformats.org/drawingml/2006/main" prst="rect">
+            <a:avLst/>
+          </a:prstGeom>
+          <a:noFill xmlns:a="http://schemas.openxmlformats.org/drawingml/2006/main"/>
+        </p:spPr>
+        <p:txBody>
+          <a:bodyPr xmlns:a="http://schemas.openxmlformats.org/drawingml/2006/main" wrap="square" lIns="0" tIns="0" rIns="0" bIns="0" anchor="ctr"/>
+          <a:lstStyle xmlns:a="http://schemas.openxmlformats.org/drawingml/2006/main"/>
+          <a:p xmlns:a="http://schemas.openxmlformats.org/drawingml/2006/main">
+            <a:pPr marL="0" indent="0">
+              <a:buNone/>
+            </a:pPr>
+            <a:r>
+              <a:rPr sz="1200">
+                <a:solidFill>
+                  <a:schemeClr val="tx2"/>
+                </a:solidFill>
+              </a:rPr>
+              <a:t>BIRL-Lite: BIRL fecha tudo</a:t>
+            </a:r>
+            <a:endParaRPr sz="1200"/>
+          </a:p>
+        </p:txBody>
+      </p:sp>
+      <p:sp>
+        <p:nvSpPr>
+          <p:cNvPr id="27" name="Motivo Semântico">
+            <a:extLst xmlns:a="http://schemas.openxmlformats.org/drawingml/2006/main">
+              <a:ext uri="{FF2B5EF4-FFF2-40B4-BE49-F238E27FC236}">
+                <a16:creationId xmlns:a16="http://schemas.microsoft.com/office/drawing/2014/main" id="{C7489AE2-D542-4D0A-A677-0690CEE93746}"/>
+              </a:ext>
+            </a:extLst>
+          </p:cNvPr>
+          <p:cNvSpPr>
+            <a:spLocks xmlns:a="http://schemas.openxmlformats.org/drawingml/2006/main" noGrp="1"/>
+          </p:cNvSpPr>
+          <p:nvPr/>
+        </p:nvSpPr>
+        <p:spPr>
+          <a:xfrm xmlns:a="http://schemas.openxmlformats.org/drawingml/2006/main">
+            <a:off x="8348472" y="3977640"/>
+            <a:ext cx="3017520" cy="411480"/>
+          </a:xfrm>
+          <a:prstGeom xmlns:a="http://schemas.openxmlformats.org/drawingml/2006/main" prst="rect">
+            <a:avLst/>
+          </a:prstGeom>
+          <a:noFill xmlns:a="http://schemas.openxmlformats.org/drawingml/2006/main"/>
+        </p:spPr>
+        <p:txBody>
+          <a:bodyPr xmlns:a="http://schemas.openxmlformats.org/drawingml/2006/main" wrap="square" lIns="0" tIns="0" rIns="0" bIns="0" anchor="ctr"/>
+          <a:lstStyle xmlns:a="http://schemas.openxmlformats.org/drawingml/2006/main"/>
+          <a:p xmlns:a="http://schemas.openxmlformats.org/drawingml/2006/main">
+            <a:pPr marL="0" indent="0">
+              <a:buNone/>
+            </a:pPr>
+            <a:r>
+              <a:rPr sz="2000" b="1">
+                <a:solidFill>
+                  <a:schemeClr val="tx1"/>
+                </a:solidFill>
+              </a:rPr>
+              <a:t>Um para cada nível</a:t>
+            </a:r>
+            <a:endParaRPr sz="2000"/>
+          </a:p>
+        </p:txBody>
+      </p:sp>
+      <p:sp>
+        <p:nvSpPr>
+          <p:cNvPr id="28" name="Faixa 1">
+            <a:extLst xmlns:a="http://schemas.openxmlformats.org/drawingml/2006/main">
+              <a:ext uri="{FF2B5EF4-FFF2-40B4-BE49-F238E27FC236}">
+                <a16:creationId xmlns:a16="http://schemas.microsoft.com/office/drawing/2014/main" id="{18F425E6-067C-4B0D-812C-924174E5CB3B}"/>
+              </a:ext>
+            </a:extLst>
+          </p:cNvPr>
+          <p:cNvSpPr>
+            <a:spLocks xmlns:a="http://schemas.openxmlformats.org/drawingml/2006/main" noGrp="1"/>
+          </p:cNvSpPr>
+          <p:nvPr/>
+        </p:nvSpPr>
+        <p:spPr>
+          <a:xfrm xmlns:a="http://schemas.openxmlformats.org/drawingml/2006/main">
+            <a:off x="548640" y="5029200"/>
+            <a:ext cx="5440680" cy="1005840"/>
+          </a:xfrm>
+          <a:prstGeom xmlns:a="http://schemas.openxmlformats.org/drawingml/2006/main" prst="roundRect">
+            <a:avLst>
+              <a:gd name="adj" fmla="val 12727"/>
+            </a:avLst>
+          </a:prstGeom>
+          <a:solidFill xmlns:a="http://schemas.openxmlformats.org/drawingml/2006/main">
+            <a:schemeClr val="tx1"/>
+          </a:solidFill>
+          <a:ln xmlns:a="http://schemas.openxmlformats.org/drawingml/2006/main" w="19050">
+            <a:solidFill>
+              <a:schemeClr val="tx1"/>
+            </a:solidFill>
+            <a:prstDash val="solid"/>
+          </a:ln>
+        </p:spPr>
+      </p:sp>
+      <p:sp>
+        <p:nvSpPr>
+          <p:cNvPr id="29" name="Texto faixa 1">
+            <a:extLst xmlns:a="http://schemas.openxmlformats.org/drawingml/2006/main">
+              <a:ext uri="{FF2B5EF4-FFF2-40B4-BE49-F238E27FC236}">
+                <a16:creationId xmlns:a16="http://schemas.microsoft.com/office/drawing/2014/main" id="{9E58DC73-C334-4346-912F-DF1F612459FB}"/>
+              </a:ext>
+            </a:extLst>
+          </p:cNvPr>
+          <p:cNvSpPr>
+            <a:spLocks xmlns:a="http://schemas.openxmlformats.org/drawingml/2006/main" noGrp="1"/>
+          </p:cNvSpPr>
+          <p:nvPr/>
+        </p:nvSpPr>
+        <p:spPr>
+          <a:xfrm xmlns:a="http://schemas.openxmlformats.org/drawingml/2006/main">
+            <a:off x="822960" y="5029200"/>
+            <a:ext cx="4892040" cy="1005840"/>
+          </a:xfrm>
+          <a:prstGeom xmlns:a="http://schemas.openxmlformats.org/drawingml/2006/main" prst="rect">
+            <a:avLst/>
+          </a:prstGeom>
+          <a:noFill xmlns:a="http://schemas.openxmlformats.org/drawingml/2006/main"/>
+        </p:spPr>
+        <p:txBody>
+          <a:bodyPr xmlns:a="http://schemas.openxmlformats.org/drawingml/2006/main" wrap="square" lIns="0" tIns="0" rIns="0" bIns="0" anchor="ctr"/>
+          <a:lstStyle xmlns:a="http://schemas.openxmlformats.org/drawingml/2006/main"/>
+          <a:p xmlns:a="http://schemas.openxmlformats.org/drawingml/2006/main">
+            <a:pPr marL="0" indent="0">
+              <a:buNone/>
+            </a:pPr>
+            <a:r>
+              <a:rPr sz="2000" b="1">
+                <a:solidFill>
+                  <a:schemeClr val="bg1"/>
+                </a:solidFill>
+              </a:rPr>
+              <a:t>A BIRL-Lite serviu só como modelo de formalização</a:t>
+            </a:r>
+            <a:endParaRPr sz="2000"/>
+          </a:p>
+        </p:txBody>
+      </p:sp>
+      <p:sp>
+        <p:nvSpPr>
+          <p:cNvPr id="30" name="Faixa 2">
+            <a:extLst xmlns:a="http://schemas.openxmlformats.org/drawingml/2006/main">
+              <a:ext uri="{FF2B5EF4-FFF2-40B4-BE49-F238E27FC236}">
+                <a16:creationId xmlns:a16="http://schemas.microsoft.com/office/drawing/2014/main" id="{D9041208-1896-4C67-8CB3-6CD846261344}"/>
+              </a:ext>
+            </a:extLst>
+          </p:cNvPr>
+          <p:cNvSpPr>
+            <a:spLocks xmlns:a="http://schemas.openxmlformats.org/drawingml/2006/main" noGrp="1"/>
+          </p:cNvSpPr>
+          <p:nvPr/>
+        </p:nvSpPr>
+        <p:spPr>
+          <a:xfrm xmlns:a="http://schemas.openxmlformats.org/drawingml/2006/main">
+            <a:off x="6199632" y="5029200"/>
+            <a:ext cx="5440680" cy="1005840"/>
+          </a:xfrm>
+          <a:prstGeom xmlns:a="http://schemas.openxmlformats.org/drawingml/2006/main" prst="roundRect">
+            <a:avLst>
+              <a:gd name="adj" fmla="val 12727"/>
+            </a:avLst>
+          </a:prstGeom>
+          <a:solidFill xmlns:a="http://schemas.openxmlformats.org/drawingml/2006/main">
+            <a:schemeClr val="tx1"/>
+          </a:solidFill>
+          <a:ln xmlns:a="http://schemas.openxmlformats.org/drawingml/2006/main" w="19050">
+            <a:solidFill>
+              <a:schemeClr val="tx1"/>
+            </a:solidFill>
+            <a:prstDash val="solid"/>
+          </a:ln>
+        </p:spPr>
+      </p:sp>
+      <p:sp>
+        <p:nvSpPr>
+          <p:cNvPr id="31" name="Texto faixa 2">
+            <a:extLst xmlns:a="http://schemas.openxmlformats.org/drawingml/2006/main">
+              <a:ext uri="{FF2B5EF4-FFF2-40B4-BE49-F238E27FC236}">
+                <a16:creationId xmlns:a16="http://schemas.microsoft.com/office/drawing/2014/main" id="{144FD62F-5C62-4F99-A783-F674EAED33A1}"/>
+              </a:ext>
+            </a:extLst>
+          </p:cNvPr>
+          <p:cNvSpPr>
+            <a:spLocks xmlns:a="http://schemas.openxmlformats.org/drawingml/2006/main" noGrp="1"/>
+          </p:cNvSpPr>
+          <p:nvPr/>
+        </p:nvSpPr>
+        <p:spPr>
+          <a:xfrm xmlns:a="http://schemas.openxmlformats.org/drawingml/2006/main">
+            <a:off x="6473952" y="5029200"/>
+            <a:ext cx="4892040" cy="1005840"/>
+          </a:xfrm>
+          <a:prstGeom xmlns:a="http://schemas.openxmlformats.org/drawingml/2006/main" prst="rect">
+            <a:avLst/>
+          </a:prstGeom>
+          <a:noFill xmlns:a="http://schemas.openxmlformats.org/drawingml/2006/main"/>
+        </p:spPr>
+        <p:txBody>
+          <a:bodyPr xmlns:a="http://schemas.openxmlformats.org/drawingml/2006/main" wrap="square" lIns="0" tIns="0" rIns="0" bIns="0" anchor="ctr"/>
+          <a:lstStyle xmlns:a="http://schemas.openxmlformats.org/drawingml/2006/main"/>
+          <a:p xmlns:a="http://schemas.openxmlformats.org/drawingml/2006/main">
+            <a:pPr marL="0" indent="0">
+              <a:buNone/>
+            </a:pPr>
+            <a:r>
+              <a:rPr sz="2000" b="1">
+                <a:solidFill>
+                  <a:schemeClr val="bg1"/>
+                </a:solidFill>
+              </a:rPr>
+              <a:t>Extras: saída com várias expressões, tipo texto e DESCANSAR_NE</a:t>
+            </a:r>
+            <a:endParaRPr sz="2000"/>
+          </a:p>
+        </p:txBody>
+      </p:sp>
+      <p:sp>
+        <p:nvSpPr>
+          <p:cNvPr id="32" name="Slide Number Placeholder 0">
+            <a:extLst xmlns:a="http://schemas.openxmlformats.org/drawingml/2006/main">
+              <a:ext uri="{FF2B5EF4-FFF2-40B4-BE49-F238E27FC236}">
+                <a16:creationId xmlns:a16="http://schemas.microsoft.com/office/drawing/2014/main" id="{FA79CE45-9589-4466-841B-27D1399767B3}"/>
+              </a:ext>
+            </a:extLst>
+          </p:cNvPr>
+          <p:cNvSpPr>
+            <a:spLocks xmlns:a="http://schemas.openxmlformats.org/drawingml/2006/main" noGrp="1"/>
+          </p:cNvSpPr>
+          <p:nvPr>
+            <p:ph type="sldNum" idx="4294967295"/>
+          </p:nvPr>
+        </p:nvSpPr>
+        <p:spPr>
+          <a:xfrm xmlns:a="http://schemas.openxmlformats.org/drawingml/2006/main">
+            <a:off x="10972800" y="6419088"/>
+            <a:ext cx="667512" cy="274320"/>
+          </a:xfrm>
+          <a:prstGeom xmlns:a="http://schemas.openxmlformats.org/drawingml/2006/main" prst="rect">
+            <a:avLst/>
+          </a:prstGeom>
+        </p:spPr>
+        <p:txBody>
+          <a:bodyPr xmlns:a="http://schemas.openxmlformats.org/drawingml/2006/main"/>
+          <a:lstStyle xmlns:a="http://schemas.openxmlformats.org/drawingml/2006/main">
+            <a:lvl1pPr>
+              <a:buNone/>
+              <a:defRPr sz="1100">
+                <a:solidFill>
+                  <a:schemeClr val="tx2"/>
+                </a:solidFill>
+              </a:defRPr>
+            </a:lvl1pPr>
+          </a:lstStyle>
+          <a:p xmlns:a="http://schemas.openxmlformats.org/drawingml/2006/main">
+            <a:pPr algn="r">
+              <a:buNone/>
+            </a:pPr>
+            <a:fld id="{F7021451-1387-4CA6-816F-3879F97B5CBC}" type="slidenum">
+              <a:rPr b="0"/>
+              <a:t>12</a:t>
+            </a:fld>
+            <a:endParaRPr/>
+          </a:p>
+        </p:txBody>
+      </p:sp>
+    </p:spTree>
+    <p:extLst>
+      <p:ext uri="{BB962C8B-B14F-4D97-AF65-F5344CB8AC3E}">
+        <p14:creationId xmlns:p14="http://schemas.microsoft.com/office/powerpoint/2010/main" val="1946482751"/>
+      </p:ext>
+    </p:extLst>
+  </p:cSld>
+</p:sld>
+</file>
+
+<file path=ppt/slides/slide16.xml><?xml version="1.0" encoding="utf-8"?>
+<p:sld xmlns:p="http://schemas.openxmlformats.org/presentationml/2006/main">
+  <p:cSld>
+    <p:spTree>
+      <p:nvGrpSpPr>
+        <p:cNvPr id="1" name=""/>
+        <p:cNvGrpSpPr/>
+        <p:nvPr/>
+      </p:nvGrpSpPr>
+      <p:grpSpPr>
+        <a:xfrm xmlns:a="http://schemas.openxmlformats.org/drawingml/2006/main"/>
+      </p:grpSpPr>
+      <p:sp>
+        <p:nvSpPr>
+          <p:cNvPr id="2" name="Text 0">
+            <a:extLst xmlns:a="http://schemas.openxmlformats.org/drawingml/2006/main">
+              <a:ext uri="{FF2B5EF4-FFF2-40B4-BE49-F238E27FC236}">
+                <a16:creationId xmlns:a16="http://schemas.microsoft.com/office/drawing/2014/main" id="{C8F652EA-5040-47A7-8E15-9B5F3E7925BB}"/>
+              </a:ext>
+            </a:extLst>
+          </p:cNvPr>
+          <p:cNvSpPr>
+            <a:spLocks xmlns:a="http://schemas.openxmlformats.org/drawingml/2006/main" noGrp="1"/>
+          </p:cNvSpPr>
+          <p:nvPr>
+            <p:ph type="title" idx="100" hasCustomPrompt="1"/>
+          </p:nvPr>
+        </p:nvSpPr>
+        <p:spPr>
+          <a:xfrm xmlns:a="http://schemas.openxmlformats.org/drawingml/2006/main">
+            <a:off x="548640" y="365760"/>
+            <a:ext cx="11091672" cy="868680"/>
+          </a:xfrm>
+          <a:prstGeom xmlns:a="http://schemas.openxmlformats.org/drawingml/2006/main" prst="rect">
+            <a:avLst/>
+          </a:prstGeom>
+          <a:noFill xmlns:a="http://schemas.openxmlformats.org/drawingml/2006/main"/>
+        </p:spPr>
+        <p:txBody>
+          <a:bodyPr xmlns:a="http://schemas.openxmlformats.org/drawingml/2006/main" wrap="square" lIns="0" tIns="0" rIns="0" bIns="0" anchor="ctr"/>
+          <a:lstStyle xmlns:a="http://schemas.openxmlformats.org/drawingml/2006/main"/>
+          <a:p xmlns:a="http://schemas.openxmlformats.org/drawingml/2006/main">
+            <a:pPr marL="0" indent="0" algn="l">
+              <a:buNone/>
+            </a:pPr>
+            <a:r>
+              <a:rPr sz="4000">
+                <a:solidFill>
+                  <a:schemeClr val="tx1"/>
+                </a:solidFill>
+              </a:rPr>
+              <a:t>Alfabeto e expressões regulares</a:t>
+            </a:r>
+            <a:endParaRPr sz="4000"/>
+          </a:p>
+        </p:txBody>
+      </p:sp>
+      <p:sp>
+        <p:nvSpPr>
+          <p:cNvPr id="4" name="Tabela de símbolos">
+            <a:extLst xmlns:a="http://schemas.openxmlformats.org/drawingml/2006/main">
+              <a:ext uri="{FF2B5EF4-FFF2-40B4-BE49-F238E27FC236}">
+                <a16:creationId xmlns:a16="http://schemas.microsoft.com/office/drawing/2014/main" id="{4FA36D1B-A440-4E24-8084-E6E651667630}"/>
+              </a:ext>
+            </a:extLst>
+          </p:cNvPr>
+          <p:cNvSpPr>
+            <a:spLocks xmlns:a="http://schemas.openxmlformats.org/drawingml/2006/main" noGrp="1"/>
+          </p:cNvSpPr>
+          <p:nvPr/>
+        </p:nvSpPr>
+        <p:spPr>
+          <a:xfrm xmlns:a="http://schemas.openxmlformats.org/drawingml/2006/main">
+            <a:off x="548640" y="1508760"/>
+            <a:ext cx="5120640" cy="2697480"/>
+          </a:xfrm>
+          <a:prstGeom xmlns:a="http://schemas.openxmlformats.org/drawingml/2006/main" prst="roundRect">
+            <a:avLst>
+              <a:gd name="adj" fmla="val 6102"/>
+            </a:avLst>
+          </a:prstGeom>
+          <a:solidFill xmlns:a="http://schemas.openxmlformats.org/drawingml/2006/main">
+            <a:schemeClr val="tx1"/>
+          </a:solidFill>
+          <a:ln xmlns:a="http://schemas.openxmlformats.org/drawingml/2006/main" w="19050">
+            <a:solidFill>
+              <a:schemeClr val="tx1"/>
+            </a:solidFill>
+            <a:prstDash val="solid"/>
+          </a:ln>
+          <a:effectLst xmlns:a="http://schemas.openxmlformats.org/drawingml/2006/main">
+            <a:outerShdw blurRad="101600" dist="50800" dir="2700000" sx="100000" sy="100000" kx="0" ky="0" algn="bl" rotWithShape="0">
+              <a:srgbClr val="15121F">
+                <a:alpha val="100000"/>
+              </a:srgbClr>
+            </a:outerShdw>
+          </a:effectLst>
+        </p:spPr>
+      </p:sp>
+      <p:sp>
+        <p:nvSpPr>
+          <p:cNvPr id="5" name="Título tabela">
+            <a:extLst xmlns:a="http://schemas.openxmlformats.org/drawingml/2006/main">
+              <a:ext uri="{FF2B5EF4-FFF2-40B4-BE49-F238E27FC236}">
+                <a16:creationId xmlns:a16="http://schemas.microsoft.com/office/drawing/2014/main" id="{050D8BBB-BD28-40BF-A8B1-1159B7E90712}"/>
+              </a:ext>
+            </a:extLst>
+          </p:cNvPr>
+          <p:cNvSpPr>
+            <a:spLocks xmlns:a="http://schemas.openxmlformats.org/drawingml/2006/main" noGrp="1"/>
+          </p:cNvSpPr>
+          <p:nvPr/>
+        </p:nvSpPr>
+        <p:spPr>
+          <a:xfrm xmlns:a="http://schemas.openxmlformats.org/drawingml/2006/main">
+            <a:off x="868680" y="1737360"/>
+            <a:ext cx="4480560" cy="365760"/>
+          </a:xfrm>
+          <a:prstGeom xmlns:a="http://schemas.openxmlformats.org/drawingml/2006/main" prst="rect">
+            <a:avLst/>
+          </a:prstGeom>
+          <a:noFill xmlns:a="http://schemas.openxmlformats.org/drawingml/2006/main"/>
+        </p:spPr>
+        <p:txBody>
+          <a:bodyPr xmlns:a="http://schemas.openxmlformats.org/drawingml/2006/main" wrap="square" lIns="0" tIns="0" rIns="0" bIns="0" anchor="ctr"/>
+          <a:lstStyle xmlns:a="http://schemas.openxmlformats.org/drawingml/2006/main"/>
+          <a:p xmlns:a="http://schemas.openxmlformats.org/drawingml/2006/main">
+            <a:pPr marL="0" indent="0">
+              <a:buNone/>
+            </a:pPr>
+            <a:r>
+              <a:rPr sz="1600" b="1">
+                <a:solidFill>
+                  <a:schemeClr val="accent6"/>
+                </a:solidFill>
+              </a:rPr>
+              <a:t>Alfabeto Σ (fora de textos e comentários)</a:t>
+            </a:r>
+            <a:endParaRPr sz="1600"/>
+          </a:p>
+        </p:txBody>
+      </p:sp>
+      <p:sp>
+        <p:nvSpPr>
+          <p:cNvPr id="6" name="Símbolo energia">
+            <a:extLst xmlns:a="http://schemas.openxmlformats.org/drawingml/2006/main">
+              <a:ext uri="{FF2B5EF4-FFF2-40B4-BE49-F238E27FC236}">
+                <a16:creationId xmlns:a16="http://schemas.microsoft.com/office/drawing/2014/main" id="{4E7EF3DA-C27F-496B-BDD4-849C4064CDB5}"/>
+              </a:ext>
+            </a:extLst>
+          </p:cNvPr>
+          <p:cNvSpPr>
+            <a:spLocks xmlns:a="http://schemas.openxmlformats.org/drawingml/2006/main" noGrp="1"/>
+          </p:cNvSpPr>
+          <p:nvPr/>
+        </p:nvSpPr>
+        <p:spPr>
+          <a:xfrm xmlns:a="http://schemas.openxmlformats.org/drawingml/2006/main">
+            <a:off x="868680" y="2331720"/>
+            <a:ext cx="4480560" cy="457200"/>
+          </a:xfrm>
+          <a:prstGeom xmlns:a="http://schemas.openxmlformats.org/drawingml/2006/main" prst="rect">
+            <a:avLst/>
+          </a:prstGeom>
+          <a:noFill xmlns:a="http://schemas.openxmlformats.org/drawingml/2006/main"/>
+        </p:spPr>
+        <p:txBody>
+          <a:bodyPr xmlns:a="http://schemas.openxmlformats.org/drawingml/2006/main" wrap="square" lIns="0" tIns="0" rIns="0" bIns="0" anchor="ctr"/>
+          <a:lstStyle xmlns:a="http://schemas.openxmlformats.org/drawingml/2006/main"/>
+          <a:p xmlns:a="http://schemas.openxmlformats.org/drawingml/2006/main">
+            <a:pPr marL="0" indent="0">
+              <a:buNone/>
+            </a:pPr>
+            <a:r>
+              <a:rPr sz="2200">
+                <a:solidFill>
+                  <a:schemeClr val="bg1"/>
+                </a:solidFill>
+                <a:latin typeface="Courier New"/>
+                <a:ea typeface="Courier New"/>
+                <a:cs typeface="Courier New"/>
+              </a:rPr>
+              <a:t>A-Z a-z 0-9 _</a:t>
+            </a:r>
+            <a:endParaRPr sz="2200"/>
+          </a:p>
+        </p:txBody>
+      </p:sp>
+      <p:sp>
+        <p:nvSpPr>
+          <p:cNvPr id="7" name="Símbolo preco">
+            <a:extLst xmlns:a="http://schemas.openxmlformats.org/drawingml/2006/main">
+              <a:ext uri="{FF2B5EF4-FFF2-40B4-BE49-F238E27FC236}">
+                <a16:creationId xmlns:a16="http://schemas.microsoft.com/office/drawing/2014/main" id="{3023EDE1-DB22-425B-908A-CFEBC41D12A0}"/>
+              </a:ext>
+            </a:extLst>
+          </p:cNvPr>
+          <p:cNvSpPr>
+            <a:spLocks xmlns:a="http://schemas.openxmlformats.org/drawingml/2006/main" noGrp="1"/>
+          </p:cNvSpPr>
+          <p:nvPr/>
+        </p:nvSpPr>
+        <p:spPr>
+          <a:xfrm xmlns:a="http://schemas.openxmlformats.org/drawingml/2006/main">
+            <a:off x="868680" y="2880360"/>
+            <a:ext cx="4480560" cy="457200"/>
+          </a:xfrm>
+          <a:prstGeom xmlns:a="http://schemas.openxmlformats.org/drawingml/2006/main" prst="rect">
+            <a:avLst/>
+          </a:prstGeom>
+          <a:noFill xmlns:a="http://schemas.openxmlformats.org/drawingml/2006/main"/>
+        </p:spPr>
+        <p:txBody>
+          <a:bodyPr xmlns:a="http://schemas.openxmlformats.org/drawingml/2006/main" wrap="square" lIns="0" tIns="0" rIns="0" bIns="0" anchor="ctr"/>
+          <a:lstStyle xmlns:a="http://schemas.openxmlformats.org/drawingml/2006/main"/>
+          <a:p xmlns:a="http://schemas.openxmlformats.org/drawingml/2006/main">
+            <a:pPr marL="0" indent="0">
+              <a:buNone/>
+            </a:pPr>
+            <a:r>
+              <a:rPr sz="2200">
+                <a:solidFill>
+                  <a:schemeClr val="accent6"/>
+                </a:solidFill>
+                <a:latin typeface="Courier New"/>
+                <a:ea typeface="Courier New"/>
+                <a:cs typeface="Courier New"/>
+              </a:rPr>
+              <a:t>+ - * / = ! &lt; &gt;</a:t>
+            </a:r>
+            <a:endParaRPr sz="2200"/>
+          </a:p>
+        </p:txBody>
+      </p:sp>
+      <p:sp>
+        <p:nvSpPr>
+          <p:cNvPr id="8" name="Símbolo pedido">
+            <a:extLst xmlns:a="http://schemas.openxmlformats.org/drawingml/2006/main">
+              <a:ext uri="{FF2B5EF4-FFF2-40B4-BE49-F238E27FC236}">
+                <a16:creationId xmlns:a16="http://schemas.microsoft.com/office/drawing/2014/main" id="{DCFA4FFB-54B2-481A-A3BC-D745A87EA179}"/>
+              </a:ext>
+            </a:extLst>
+          </p:cNvPr>
+          <p:cNvSpPr>
+            <a:spLocks xmlns:a="http://schemas.openxmlformats.org/drawingml/2006/main" noGrp="1"/>
+          </p:cNvSpPr>
+          <p:nvPr/>
+        </p:nvSpPr>
+        <p:spPr>
+          <a:xfrm xmlns:a="http://schemas.openxmlformats.org/drawingml/2006/main">
+            <a:off x="868680" y="3429000"/>
+            <a:ext cx="4480560" cy="457200"/>
+          </a:xfrm>
+          <a:prstGeom xmlns:a="http://schemas.openxmlformats.org/drawingml/2006/main" prst="rect">
+            <a:avLst/>
+          </a:prstGeom>
+          <a:noFill xmlns:a="http://schemas.openxmlformats.org/drawingml/2006/main"/>
+        </p:spPr>
+        <p:txBody>
+          <a:bodyPr xmlns:a="http://schemas.openxmlformats.org/drawingml/2006/main" wrap="square" lIns="0" tIns="0" rIns="0" bIns="0" anchor="ctr"/>
+          <a:lstStyle xmlns:a="http://schemas.openxmlformats.org/drawingml/2006/main"/>
+          <a:p xmlns:a="http://schemas.openxmlformats.org/drawingml/2006/main">
+            <a:pPr marL="0" indent="0">
+              <a:buNone/>
+            </a:pPr>
+            <a:r>
+              <a:rPr sz="2200">
+                <a:solidFill>
+                  <a:schemeClr val="accent6"/>
+                </a:solidFill>
+                <a:latin typeface="Courier New"/>
+                <a:ea typeface="Courier New"/>
+                <a:cs typeface="Courier New"/>
+              </a:rPr>
+              <a:t>( ) , ; . "</a:t>
+            </a:r>
+            <a:r>
+              <a:rPr sz="2200">
+                <a:solidFill>
+                  <a:schemeClr val="bg1"/>
+                </a:solidFill>
+                <a:latin typeface="Courier New"/>
+                <a:ea typeface="Courier New"/>
+                <a:cs typeface="Courier New"/>
+              </a:rPr>
+              <a:t> brancos</a:t>
+            </a:r>
+            <a:endParaRPr sz="2200"/>
+          </a:p>
+        </p:txBody>
+      </p:sp>
+      <p:sp>
+        <p:nvSpPr>
+          <p:cNvPr id="9" name="Verificação 1">
+            <a:extLst xmlns:a="http://schemas.openxmlformats.org/drawingml/2006/main">
+              <a:ext uri="{FF2B5EF4-FFF2-40B4-BE49-F238E27FC236}">
+                <a16:creationId xmlns:a16="http://schemas.microsoft.com/office/drawing/2014/main" id="{06D99708-7BB5-4FAB-B371-1D3208E5B5F3}"/>
+              </a:ext>
+            </a:extLst>
+          </p:cNvPr>
+          <p:cNvSpPr>
+            <a:spLocks xmlns:a="http://schemas.openxmlformats.org/drawingml/2006/main" noGrp="1"/>
+          </p:cNvSpPr>
+          <p:nvPr/>
+        </p:nvSpPr>
+        <p:spPr>
+          <a:xfrm xmlns:a="http://schemas.openxmlformats.org/drawingml/2006/main">
+            <a:off x="5943600" y="1508760"/>
+            <a:ext cx="5696712" cy="585216"/>
+          </a:xfrm>
+          <a:prstGeom xmlns:a="http://schemas.openxmlformats.org/drawingml/2006/main" prst="roundRect">
+            <a:avLst>
+              <a:gd name="adj" fmla="val 18750"/>
+            </a:avLst>
+          </a:prstGeom>
+          <a:solidFill xmlns:a="http://schemas.openxmlformats.org/drawingml/2006/main">
+            <a:schemeClr val="bg1"/>
+          </a:solidFill>
+          <a:ln xmlns:a="http://schemas.openxmlformats.org/drawingml/2006/main" w="19050">
+            <a:solidFill>
+              <a:schemeClr val="tx1"/>
+            </a:solidFill>
+            <a:prstDash val="solid"/>
+          </a:ln>
+          <a:effectLst xmlns:a="http://schemas.openxmlformats.org/drawingml/2006/main">
+            <a:outerShdw blurRad="101600" dist="50800" dir="2700000" sx="100000" sy="100000" kx="0" ky="0" algn="bl" rotWithShape="0">
+              <a:srgbClr val="15121F">
+                <a:alpha val="100000"/>
+              </a:srgbClr>
+            </a:outerShdw>
+          </a:effectLst>
+        </p:spPr>
+      </p:sp>
+      <p:sp>
+        <p:nvSpPr>
+          <p:cNvPr id="12" name="Texto verificação 1">
+            <a:extLst xmlns:a="http://schemas.openxmlformats.org/drawingml/2006/main">
+              <a:ext uri="{FF2B5EF4-FFF2-40B4-BE49-F238E27FC236}">
+                <a16:creationId xmlns:a16="http://schemas.microsoft.com/office/drawing/2014/main" id="{D0850B5E-EE73-43C2-B83F-AB5E3801840D}"/>
+              </a:ext>
+            </a:extLst>
+          </p:cNvPr>
+          <p:cNvSpPr>
+            <a:spLocks xmlns:a="http://schemas.openxmlformats.org/drawingml/2006/main" noGrp="1"/>
+          </p:cNvSpPr>
+          <p:nvPr/>
+        </p:nvSpPr>
+        <p:spPr>
+          <a:xfrm xmlns:a="http://schemas.openxmlformats.org/drawingml/2006/main">
+            <a:off x="6217920" y="1508760"/>
+            <a:ext cx="5303520" cy="585216"/>
+          </a:xfrm>
+          <a:prstGeom xmlns:a="http://schemas.openxmlformats.org/drawingml/2006/main" prst="rect">
+            <a:avLst/>
+          </a:prstGeom>
+          <a:noFill xmlns:a="http://schemas.openxmlformats.org/drawingml/2006/main"/>
+        </p:spPr>
+        <p:txBody>
+          <a:bodyPr xmlns:a="http://schemas.openxmlformats.org/drawingml/2006/main" wrap="square" lIns="0" tIns="0" rIns="0" bIns="0" anchor="ctr"/>
+          <a:lstStyle xmlns:a="http://schemas.openxmlformats.org/drawingml/2006/main"/>
+          <a:p xmlns:a="http://schemas.openxmlformats.org/drawingml/2006/main">
+            <a:pPr marL="0" indent="0">
+              <a:buNone/>
+            </a:pPr>
+            <a:r>
+              <a:rPr sz="1800" b="1">
+                <a:solidFill>
+                  <a:schemeClr val="tx1"/>
+                </a:solidFill>
+              </a:rPr>
+              <a:t>INTEGER</a:t>
+            </a:r>
+            <a:r>
+              <a:rPr sz="1600" b="0">
+                <a:solidFill>
+                  <a:schemeClr val="tx1"/>
+                </a:solidFill>
+                <a:latin typeface="Courier New"/>
+              </a:rPr>
+              <a:t>  [0-9]+</a:t>
+            </a:r>
+            <a:endParaRPr sz="1800"/>
+          </a:p>
+        </p:txBody>
+      </p:sp>
+      <p:sp>
+        <p:nvSpPr>
+          <p:cNvPr id="13" name="Verificação 2">
+            <a:extLst xmlns:a="http://schemas.openxmlformats.org/drawingml/2006/main">
+              <a:ext uri="{FF2B5EF4-FFF2-40B4-BE49-F238E27FC236}">
+                <a16:creationId xmlns:a16="http://schemas.microsoft.com/office/drawing/2014/main" id="{0E9C887A-482D-40E4-B4B1-DE62C461D826}"/>
+              </a:ext>
+            </a:extLst>
+          </p:cNvPr>
+          <p:cNvSpPr>
+            <a:spLocks xmlns:a="http://schemas.openxmlformats.org/drawingml/2006/main" noGrp="1"/>
+          </p:cNvSpPr>
+          <p:nvPr/>
+        </p:nvSpPr>
+        <p:spPr>
+          <a:xfrm xmlns:a="http://schemas.openxmlformats.org/drawingml/2006/main">
+            <a:off x="5943600" y="2203704"/>
+            <a:ext cx="5696712" cy="585216"/>
+          </a:xfrm>
+          <a:prstGeom xmlns:a="http://schemas.openxmlformats.org/drawingml/2006/main" prst="roundRect">
+            <a:avLst>
+              <a:gd name="adj" fmla="val 18750"/>
+            </a:avLst>
+          </a:prstGeom>
+          <a:solidFill xmlns:a="http://schemas.openxmlformats.org/drawingml/2006/main">
+            <a:schemeClr val="bg1"/>
+          </a:solidFill>
+          <a:ln xmlns:a="http://schemas.openxmlformats.org/drawingml/2006/main" w="19050">
+            <a:solidFill>
+              <a:schemeClr val="tx1"/>
+            </a:solidFill>
+            <a:prstDash val="solid"/>
+          </a:ln>
+          <a:effectLst xmlns:a="http://schemas.openxmlformats.org/drawingml/2006/main">
+            <a:outerShdw blurRad="101600" dist="50800" dir="2700000" sx="100000" sy="100000" kx="0" ky="0" algn="bl" rotWithShape="0">
+              <a:srgbClr val="15121F">
+                <a:alpha val="100000"/>
+              </a:srgbClr>
+            </a:outerShdw>
+          </a:effectLst>
+        </p:spPr>
+      </p:sp>
+      <p:sp>
+        <p:nvSpPr>
+          <p:cNvPr id="16" name="Texto verificação 2">
+            <a:extLst xmlns:a="http://schemas.openxmlformats.org/drawingml/2006/main">
+              <a:ext uri="{FF2B5EF4-FFF2-40B4-BE49-F238E27FC236}">
+                <a16:creationId xmlns:a16="http://schemas.microsoft.com/office/drawing/2014/main" id="{BDB7C4E9-C2B5-496D-A669-01359E9C72ED}"/>
+              </a:ext>
+            </a:extLst>
+          </p:cNvPr>
+          <p:cNvSpPr>
+            <a:spLocks xmlns:a="http://schemas.openxmlformats.org/drawingml/2006/main" noGrp="1"/>
+          </p:cNvSpPr>
+          <p:nvPr/>
+        </p:nvSpPr>
+        <p:spPr>
+          <a:xfrm xmlns:a="http://schemas.openxmlformats.org/drawingml/2006/main">
+            <a:off x="6217920" y="2203704"/>
+            <a:ext cx="5303520" cy="585216"/>
+          </a:xfrm>
+          <a:prstGeom xmlns:a="http://schemas.openxmlformats.org/drawingml/2006/main" prst="rect">
+            <a:avLst/>
+          </a:prstGeom>
+          <a:noFill xmlns:a="http://schemas.openxmlformats.org/drawingml/2006/main"/>
+        </p:spPr>
+        <p:txBody>
+          <a:bodyPr xmlns:a="http://schemas.openxmlformats.org/drawingml/2006/main" wrap="square" lIns="0" tIns="0" rIns="0" bIns="0" anchor="ctr"/>
+          <a:lstStyle xmlns:a="http://schemas.openxmlformats.org/drawingml/2006/main"/>
+          <a:p xmlns:a="http://schemas.openxmlformats.org/drawingml/2006/main">
+            <a:pPr marL="0" indent="0">
+              <a:buNone/>
+            </a:pPr>
+            <a:r>
+              <a:rPr sz="1800" b="1">
+                <a:solidFill>
+                  <a:schemeClr val="tx1"/>
+                </a:solidFill>
+              </a:rPr>
+              <a:t>REAL</a:t>
+            </a:r>
+            <a:r>
+              <a:rPr sz="1600" b="0">
+                <a:solidFill>
+                  <a:schemeClr val="tx1"/>
+                </a:solidFill>
+                <a:latin typeface="Courier New"/>
+              </a:rPr>
+              <a:t>  [0-9]+\.[0-9]+</a:t>
+            </a:r>
+            <a:endParaRPr sz="1800"/>
+          </a:p>
+        </p:txBody>
+      </p:sp>
+      <p:sp>
+        <p:nvSpPr>
+          <p:cNvPr id="17" name="Verificação 3">
+            <a:extLst xmlns:a="http://schemas.openxmlformats.org/drawingml/2006/main">
+              <a:ext uri="{FF2B5EF4-FFF2-40B4-BE49-F238E27FC236}">
+                <a16:creationId xmlns:a16="http://schemas.microsoft.com/office/drawing/2014/main" id="{93730D1D-923D-4550-891C-2E1378CD4125}"/>
+              </a:ext>
+            </a:extLst>
+          </p:cNvPr>
+          <p:cNvSpPr>
+            <a:spLocks xmlns:a="http://schemas.openxmlformats.org/drawingml/2006/main" noGrp="1"/>
+          </p:cNvSpPr>
+          <p:nvPr/>
+        </p:nvSpPr>
+        <p:spPr>
+          <a:xfrm xmlns:a="http://schemas.openxmlformats.org/drawingml/2006/main">
+            <a:off x="5943600" y="2898648"/>
+            <a:ext cx="5696712" cy="585216"/>
+          </a:xfrm>
+          <a:prstGeom xmlns:a="http://schemas.openxmlformats.org/drawingml/2006/main" prst="roundRect">
+            <a:avLst>
+              <a:gd name="adj" fmla="val 18750"/>
+            </a:avLst>
+          </a:prstGeom>
+          <a:solidFill xmlns:a="http://schemas.openxmlformats.org/drawingml/2006/main">
+            <a:schemeClr val="bg1"/>
+          </a:solidFill>
+          <a:ln xmlns:a="http://schemas.openxmlformats.org/drawingml/2006/main" w="19050">
+            <a:solidFill>
+              <a:schemeClr val="tx1"/>
+            </a:solidFill>
+            <a:prstDash val="solid"/>
+          </a:ln>
+          <a:effectLst xmlns:a="http://schemas.openxmlformats.org/drawingml/2006/main">
+            <a:outerShdw blurRad="101600" dist="50800" dir="2700000" sx="100000" sy="100000" kx="0" ky="0" algn="bl" rotWithShape="0">
+              <a:srgbClr val="15121F">
+                <a:alpha val="100000"/>
+              </a:srgbClr>
+            </a:outerShdw>
+          </a:effectLst>
+        </p:spPr>
+      </p:sp>
+      <p:sp>
+        <p:nvSpPr>
+          <p:cNvPr id="20" name="Texto verificação 3">
+            <a:extLst xmlns:a="http://schemas.openxmlformats.org/drawingml/2006/main">
+              <a:ext uri="{FF2B5EF4-FFF2-40B4-BE49-F238E27FC236}">
+                <a16:creationId xmlns:a16="http://schemas.microsoft.com/office/drawing/2014/main" id="{76829860-384E-4BB5-87EA-B0A0A201CCA0}"/>
+              </a:ext>
+            </a:extLst>
+          </p:cNvPr>
+          <p:cNvSpPr>
+            <a:spLocks xmlns:a="http://schemas.openxmlformats.org/drawingml/2006/main" noGrp="1"/>
+          </p:cNvSpPr>
+          <p:nvPr/>
+        </p:nvSpPr>
+        <p:spPr>
+          <a:xfrm xmlns:a="http://schemas.openxmlformats.org/drawingml/2006/main">
+            <a:off x="6217920" y="2898648"/>
+            <a:ext cx="5303520" cy="585216"/>
+          </a:xfrm>
+          <a:prstGeom xmlns:a="http://schemas.openxmlformats.org/drawingml/2006/main" prst="rect">
+            <a:avLst/>
+          </a:prstGeom>
+          <a:noFill xmlns:a="http://schemas.openxmlformats.org/drawingml/2006/main"/>
+        </p:spPr>
+        <p:txBody>
+          <a:bodyPr xmlns:a="http://schemas.openxmlformats.org/drawingml/2006/main" wrap="square" lIns="0" tIns="0" rIns="0" bIns="0" anchor="ctr"/>
+          <a:lstStyle xmlns:a="http://schemas.openxmlformats.org/drawingml/2006/main"/>
+          <a:p xmlns:a="http://schemas.openxmlformats.org/drawingml/2006/main">
+            <a:pPr marL="0" indent="0">
+              <a:buNone/>
+            </a:pPr>
+            <a:r>
+              <a:rPr sz="1800" b="1">
+                <a:solidFill>
+                  <a:schemeClr val="tx1"/>
+                </a:solidFill>
+              </a:rPr>
+              <a:t>IDENTIFIER</a:t>
+            </a:r>
+            <a:r>
+              <a:rPr sz="1600" b="0">
+                <a:solidFill>
+                  <a:schemeClr val="tx1"/>
+                </a:solidFill>
+                <a:latin typeface="Courier New"/>
+              </a:rPr>
+              <a:t>  [A-Za-z_][A-Za-z0-9_]*</a:t>
+            </a:r>
+            <a:endParaRPr sz="1800"/>
+          </a:p>
+        </p:txBody>
+      </p:sp>
+      <p:sp>
+        <p:nvSpPr>
+          <p:cNvPr id="21" name="Verificação 4">
+            <a:extLst xmlns:a="http://schemas.openxmlformats.org/drawingml/2006/main">
+              <a:ext uri="{FF2B5EF4-FFF2-40B4-BE49-F238E27FC236}">
+                <a16:creationId xmlns:a16="http://schemas.microsoft.com/office/drawing/2014/main" id="{7CB94101-3A23-46CD-B4DE-C45721BBF9CE}"/>
+              </a:ext>
+            </a:extLst>
+          </p:cNvPr>
+          <p:cNvSpPr>
+            <a:spLocks xmlns:a="http://schemas.openxmlformats.org/drawingml/2006/main" noGrp="1"/>
+          </p:cNvSpPr>
+          <p:nvPr/>
+        </p:nvSpPr>
+        <p:spPr>
+          <a:xfrm xmlns:a="http://schemas.openxmlformats.org/drawingml/2006/main">
+            <a:off x="5943600" y="3593592"/>
+            <a:ext cx="5696712" cy="585216"/>
+          </a:xfrm>
+          <a:prstGeom xmlns:a="http://schemas.openxmlformats.org/drawingml/2006/main" prst="roundRect">
+            <a:avLst>
+              <a:gd name="adj" fmla="val 18750"/>
+            </a:avLst>
+          </a:prstGeom>
+          <a:solidFill xmlns:a="http://schemas.openxmlformats.org/drawingml/2006/main">
+            <a:schemeClr val="bg1"/>
+          </a:solidFill>
+          <a:ln xmlns:a="http://schemas.openxmlformats.org/drawingml/2006/main" w="19050">
+            <a:solidFill>
+              <a:schemeClr val="tx1"/>
+            </a:solidFill>
+            <a:prstDash val="solid"/>
+          </a:ln>
+          <a:effectLst xmlns:a="http://schemas.openxmlformats.org/drawingml/2006/main">
+            <a:outerShdw blurRad="101600" dist="50800" dir="2700000" sx="100000" sy="100000" kx="0" ky="0" algn="bl" rotWithShape="0">
+              <a:srgbClr val="15121F">
+                <a:alpha val="100000"/>
+              </a:srgbClr>
+            </a:outerShdw>
+          </a:effectLst>
+        </p:spPr>
+      </p:sp>
+      <p:sp>
+        <p:nvSpPr>
+          <p:cNvPr id="24" name="Texto verificação 4">
+            <a:extLst xmlns:a="http://schemas.openxmlformats.org/drawingml/2006/main">
+              <a:ext uri="{FF2B5EF4-FFF2-40B4-BE49-F238E27FC236}">
+                <a16:creationId xmlns:a16="http://schemas.microsoft.com/office/drawing/2014/main" id="{CC27D786-57E6-4C52-82B6-38BB50548231}"/>
+              </a:ext>
+            </a:extLst>
+          </p:cNvPr>
+          <p:cNvSpPr>
+            <a:spLocks xmlns:a="http://schemas.openxmlformats.org/drawingml/2006/main" noGrp="1"/>
+          </p:cNvSpPr>
+          <p:nvPr/>
+        </p:nvSpPr>
+        <p:spPr>
+          <a:xfrm xmlns:a="http://schemas.openxmlformats.org/drawingml/2006/main">
+            <a:off x="6217920" y="3593592"/>
+            <a:ext cx="5303520" cy="585216"/>
+          </a:xfrm>
+          <a:prstGeom xmlns:a="http://schemas.openxmlformats.org/drawingml/2006/main" prst="rect">
+            <a:avLst/>
+          </a:prstGeom>
+          <a:noFill xmlns:a="http://schemas.openxmlformats.org/drawingml/2006/main"/>
+        </p:spPr>
+        <p:txBody>
+          <a:bodyPr xmlns:a="http://schemas.openxmlformats.org/drawingml/2006/main" wrap="square" lIns="0" tIns="0" rIns="0" bIns="0" anchor="ctr"/>
+          <a:lstStyle xmlns:a="http://schemas.openxmlformats.org/drawingml/2006/main"/>
+          <a:p xmlns:a="http://schemas.openxmlformats.org/drawingml/2006/main">
+            <a:pPr marL="0" indent="0">
+              <a:buNone/>
+            </a:pPr>
+            <a:r>
+              <a:rPr sz="1800" b="1">
+                <a:solidFill>
+                  <a:schemeClr val="tx1"/>
+                </a:solidFill>
+              </a:rPr>
+              <a:t>STRING</a:t>
+            </a:r>
+            <a:r>
+              <a:rPr sz="1600" b="0">
+                <a:solidFill>
+                  <a:schemeClr val="tx1"/>
+                </a:solidFill>
+                <a:latin typeface="Courier New"/>
+              </a:rPr>
+              <a:t>  "([^"\\]|\\["\\nrt])*"</a:t>
+            </a:r>
+            <a:endParaRPr sz="1800"/>
+          </a:p>
+        </p:txBody>
+      </p:sp>
+      <p:sp>
+        <p:nvSpPr>
+          <p:cNvPr id="25" name="Terminal erro">
+            <a:extLst xmlns:a="http://schemas.openxmlformats.org/drawingml/2006/main">
+              <a:ext uri="{FF2B5EF4-FFF2-40B4-BE49-F238E27FC236}">
+                <a16:creationId xmlns:a16="http://schemas.microsoft.com/office/drawing/2014/main" id="{A900189B-2913-4210-9194-E67A87FADAF9}"/>
+              </a:ext>
+            </a:extLst>
+          </p:cNvPr>
+          <p:cNvSpPr>
+            <a:spLocks xmlns:a="http://schemas.openxmlformats.org/drawingml/2006/main" noGrp="1"/>
+          </p:cNvSpPr>
+          <p:nvPr/>
+        </p:nvSpPr>
+        <p:spPr>
+          <a:xfrm xmlns:a="http://schemas.openxmlformats.org/drawingml/2006/main">
+            <a:off x="548640" y="4572000"/>
+            <a:ext cx="11091672" cy="1600200"/>
+          </a:xfrm>
+          <a:prstGeom xmlns:a="http://schemas.openxmlformats.org/drawingml/2006/main" prst="roundRect">
+            <a:avLst>
+              <a:gd name="adj" fmla="val 10286"/>
+            </a:avLst>
+          </a:prstGeom>
+          <a:solidFill xmlns:a="http://schemas.openxmlformats.org/drawingml/2006/main">
+            <a:schemeClr val="tx1"/>
+          </a:solidFill>
+          <a:ln xmlns:a="http://schemas.openxmlformats.org/drawingml/2006/main" w="19050">
+            <a:solidFill>
+              <a:schemeClr val="tx1"/>
+            </a:solidFill>
+            <a:prstDash val="solid"/>
+          </a:ln>
+          <a:effectLst xmlns:a="http://schemas.openxmlformats.org/drawingml/2006/main">
+            <a:outerShdw blurRad="101600" dist="50800" dir="2700000" sx="100000" sy="100000" kx="0" ky="0" algn="bl" rotWithShape="0">
+              <a:srgbClr val="15121F">
+                <a:alpha val="100000"/>
+              </a:srgbClr>
+            </a:outerShdw>
+          </a:effectLst>
+        </p:spPr>
+      </p:sp>
+      <p:sp>
+        <p:nvSpPr>
+          <p:cNvPr id="26" name="Código erro">
+            <a:extLst xmlns:a="http://schemas.openxmlformats.org/drawingml/2006/main">
+              <a:ext uri="{FF2B5EF4-FFF2-40B4-BE49-F238E27FC236}">
+                <a16:creationId xmlns:a16="http://schemas.microsoft.com/office/drawing/2014/main" id="{2436FE06-B9ED-45AC-B3E2-0396FCDC8549}"/>
+              </a:ext>
+            </a:extLst>
+          </p:cNvPr>
+          <p:cNvSpPr>
+            <a:spLocks xmlns:a="http://schemas.openxmlformats.org/drawingml/2006/main" noGrp="1"/>
+          </p:cNvSpPr>
+          <p:nvPr/>
+        </p:nvSpPr>
+        <p:spPr>
+          <a:xfrm xmlns:a="http://schemas.openxmlformats.org/drawingml/2006/main">
+            <a:off x="914400" y="4754880"/>
+            <a:ext cx="10332720" cy="548640"/>
+          </a:xfrm>
+          <a:prstGeom xmlns:a="http://schemas.openxmlformats.org/drawingml/2006/main" prst="rect">
+            <a:avLst/>
+          </a:prstGeom>
+          <a:noFill xmlns:a="http://schemas.openxmlformats.org/drawingml/2006/main"/>
+        </p:spPr>
+        <p:txBody>
+          <a:bodyPr xmlns:a="http://schemas.openxmlformats.org/drawingml/2006/main" wrap="square" lIns="0" tIns="0" rIns="0" bIns="0" anchor="ctr"/>
+          <a:lstStyle xmlns:a="http://schemas.openxmlformats.org/drawingml/2006/main"/>
+          <a:p xmlns:a="http://schemas.openxmlformats.org/drawingml/2006/main">
+            <a:pPr marL="0" indent="0">
+              <a:buNone/>
+            </a:pPr>
+            <a:r>
+              <a:rPr sz="2200" b="1">
+                <a:solidFill>
+                  <a:schemeClr val="accent1"/>
+                </a:solidFill>
+                <a:latin typeface="Courier New"/>
+                <a:ea typeface="Courier New"/>
+                <a:cs typeface="Courier New"/>
+              </a:rPr>
+              <a:t>RECEBA</a:t>
+            </a:r>
+            <a:r>
+              <a:rPr sz="2200" b="1">
+                <a:solidFill>
+                  <a:schemeClr val="bg1"/>
+                </a:solidFill>
+                <a:latin typeface="Courier New"/>
+                <a:ea typeface="Courier New"/>
+                <a:cs typeface="Courier New"/>
+              </a:rPr>
+              <a:t> numero = numero @ 2;</a:t>
+            </a:r>
+            <a:endParaRPr sz="2200"/>
+          </a:p>
+        </p:txBody>
+      </p:sp>
+      <p:sp>
+        <p:nvSpPr>
+          <p:cNvPr id="27" name="Mensagem erro">
+            <a:extLst xmlns:a="http://schemas.openxmlformats.org/drawingml/2006/main">
+              <a:ext uri="{FF2B5EF4-FFF2-40B4-BE49-F238E27FC236}">
+                <a16:creationId xmlns:a16="http://schemas.microsoft.com/office/drawing/2014/main" id="{4D060FD2-2DBB-43BD-822C-AC28DA18E265}"/>
+              </a:ext>
+            </a:extLst>
+          </p:cNvPr>
+          <p:cNvSpPr>
+            <a:spLocks xmlns:a="http://schemas.openxmlformats.org/drawingml/2006/main" noGrp="1"/>
+          </p:cNvSpPr>
+          <p:nvPr/>
+        </p:nvSpPr>
+        <p:spPr>
+          <a:xfrm xmlns:a="http://schemas.openxmlformats.org/drawingml/2006/main">
+            <a:off x="914400" y="5394960"/>
+            <a:ext cx="10332720" cy="548640"/>
+          </a:xfrm>
+          <a:prstGeom xmlns:a="http://schemas.openxmlformats.org/drawingml/2006/main" prst="rect">
+            <a:avLst/>
+          </a:prstGeom>
+          <a:noFill xmlns:a="http://schemas.openxmlformats.org/drawingml/2006/main"/>
+        </p:spPr>
+        <p:txBody>
+          <a:bodyPr xmlns:a="http://schemas.openxmlformats.org/drawingml/2006/main" wrap="square" lIns="0" tIns="0" rIns="0" bIns="0" anchor="ctr"/>
+          <a:lstStyle xmlns:a="http://schemas.openxmlformats.org/drawingml/2006/main"/>
+          <a:p xmlns:a="http://schemas.openxmlformats.org/drawingml/2006/main">
+            <a:pPr marL="0" indent="0">
+              <a:buNone/>
+            </a:pPr>
+            <a:r>
+              <a:rPr sz="2000" b="1">
+                <a:solidFill>
+                  <a:schemeClr val="accent2"/>
+                </a:solidFill>
+                <a:latin typeface="Courier New"/>
+                <a:ea typeface="Courier New"/>
+                <a:cs typeface="Courier New"/>
+              </a:rPr>
+              <a:t>Erro léxico</a:t>
+            </a:r>
+            <a:r>
+              <a:rPr sz="2000">
+                <a:solidFill>
+                  <a:schemeClr val="bg1"/>
+                </a:solidFill>
+                <a:latin typeface="Courier New"/>
+                <a:ea typeface="Courier New"/>
+                <a:cs typeface="Courier New"/>
+              </a:rPr>
+              <a:t> na linha 3, coluna 24: símbolo inválido '@'</a:t>
+            </a:r>
+            <a:endParaRPr sz="2000"/>
+          </a:p>
+        </p:txBody>
+      </p:sp>
+      <p:sp>
+        <p:nvSpPr>
+          <p:cNvPr id="28" name="Slide Number Placeholder 0">
+            <a:extLst xmlns:a="http://schemas.openxmlformats.org/drawingml/2006/main">
+              <a:ext uri="{FF2B5EF4-FFF2-40B4-BE49-F238E27FC236}">
+                <a16:creationId xmlns:a16="http://schemas.microsoft.com/office/drawing/2014/main" id="{F624F7E1-D81D-4B49-9FA8-0453B3217D3B}"/>
+              </a:ext>
+            </a:extLst>
+          </p:cNvPr>
+          <p:cNvSpPr>
+            <a:spLocks xmlns:a="http://schemas.openxmlformats.org/drawingml/2006/main" noGrp="1"/>
+          </p:cNvSpPr>
+          <p:nvPr>
+            <p:ph type="sldNum" idx="4294967295"/>
+          </p:nvPr>
+        </p:nvSpPr>
+        <p:spPr>
+          <a:xfrm xmlns:a="http://schemas.openxmlformats.org/drawingml/2006/main">
+            <a:off x="10972800" y="6419088"/>
+            <a:ext cx="667512" cy="274320"/>
+          </a:xfrm>
+          <a:prstGeom xmlns:a="http://schemas.openxmlformats.org/drawingml/2006/main" prst="rect">
+            <a:avLst/>
+          </a:prstGeom>
+        </p:spPr>
+        <p:txBody>
+          <a:bodyPr xmlns:a="http://schemas.openxmlformats.org/drawingml/2006/main"/>
+          <a:lstStyle xmlns:a="http://schemas.openxmlformats.org/drawingml/2006/main">
+            <a:lvl1pPr>
+              <a:buNone/>
+              <a:defRPr sz="1100">
+                <a:solidFill>
+                  <a:schemeClr val="tx2"/>
+                </a:solidFill>
+              </a:defRPr>
+            </a:lvl1pPr>
+          </a:lstStyle>
+          <a:p xmlns:a="http://schemas.openxmlformats.org/drawingml/2006/main">
+            <a:pPr algn="r">
+              <a:buNone/>
+            </a:pPr>
+            <a:fld id="{F7021451-1387-4CA6-816F-3879F97B5CBC}" type="slidenum">
+              <a:rPr b="0"/>
+              <a:t>8</a:t>
+            </a:fld>
+            <a:endParaRPr/>
+          </a:p>
+        </p:txBody>
+      </p:sp>
+    </p:spTree>
+    <p:extLst>
+      <p:ext uri="{BB962C8B-B14F-4D97-AF65-F5344CB8AC3E}">
+        <p14:creationId xmlns:p14="http://schemas.microsoft.com/office/powerpoint/2010/main" val="603948317"/>
       </p:ext>
     </p:extLst>
   </p:cSld>
@@ -14415,7 +16725,7 @@
                 <a:ea typeface="Impact"/>
                 <a:cs typeface="Impact"/>
               </a:rPr>
-              <a:t>Indentação</a:t>
+              <a:t>G=(V,T,P,S)</a:t>
             </a:r>
             <a:endParaRPr sz="3600"/>
           </a:p>
@@ -14458,7 +16768,21 @@
                   <a:schemeClr val="tx1"/>
                 </a:solidFill>
               </a:rPr>
-              <a:t>serve para leitura</a:t>
+              <a:t>S = program</a:t>
+            </a:r>
+            <a:endParaRPr sz="2000"/>
+          </a:p>
+          <a:p xmlns:a="http://schemas.openxmlformats.org/drawingml/2006/main">
+            <a:pPr marL="0" indent="0">
+              <a:buNone/>
+            </a:pPr>
+            <a:r>
+              <a:rPr sz="2000" b="1">
+                <a:solidFill>
+                  <a:schemeClr val="tx1"/>
+                </a:solidFill>
+              </a:rPr>
+              <a:t>V com 17 não-terminais</a:t>
             </a:r>
             <a:endParaRPr sz="2000"/>
           </a:p>

</xml_diff>